<commit_message>
Simplify framework PPT to boxes, lines, and time sync
Strip dense copy; keep layered stack, /cmd_vel seam, repo scope,
and a minimal use_sim_time /clock note.

Co-authored-by: zhangqiwen1112 <zhangqiwen1112@users.noreply.github.com>
</commit_message>
<xml_diff>
--- a/docs/framework_overview_one_page.pptx
+++ b/docs/framework_overview_one_page.pptx
@@ -3103,7 +3103,7 @@
             <a:avLst/>
           </a:prstGeom>
           <a:solidFill>
-            <a:srgbClr val="F4F7FB"/>
+            <a:srgbClr val="FAFBFC"/>
           </a:solidFill>
           <a:ln>
             <a:noFill/>
@@ -3133,20 +3133,94 @@
       </p:sp>
       <p:sp>
         <p:nvSpPr>
-          <p:cNvPr id="3" name="Rectangle 2"/>
-          <p:cNvSpPr/>
+          <p:cNvPr id="3" name="TextBox 2"/>
+          <p:cNvSpPr txBox="1"/>
           <p:nvPr/>
         </p:nvSpPr>
         <p:spPr>
           <a:xfrm>
-            <a:off x="0" y="0"/>
-            <a:ext cx="12191695" cy="868680"/>
+            <a:off x="457200" y="256032"/>
+            <a:ext cx="10972800" cy="365760"/>
           </a:xfrm>
           <a:prstGeom prst="rect">
             <a:avLst/>
           </a:prstGeom>
+          <a:noFill/>
+        </p:spPr>
+        <p:txBody>
+          <a:bodyPr wrap="none">
+            <a:spAutoFit/>
+          </a:bodyPr>
+          <a:lstStyle/>
+          <a:p>
+            <a:pPr algn="l"/>
+            <a:r>
+              <a:rPr sz="2800" b="1">
+                <a:solidFill>
+                  <a:srgbClr val="0F172A"/>
+                </a:solidFill>
+                <a:latin typeface="Microsoft YaHei"/>
+                <a:ea typeface="Microsoft YaHei"/>
+              </a:rPr>
+              <a:t>熟悉的框架</a:t>
+            </a:r>
+          </a:p>
+        </p:txBody>
+      </p:sp>
+      <p:sp>
+        <p:nvSpPr>
+          <p:cNvPr id="4" name="TextBox 3"/>
+          <p:cNvSpPr txBox="1"/>
+          <p:nvPr/>
+        </p:nvSpPr>
+        <p:spPr>
+          <a:xfrm>
+            <a:off x="457200" y="640080"/>
+            <a:ext cx="10972800" cy="274320"/>
+          </a:xfrm>
+          <a:prstGeom prst="rect">
+            <a:avLst/>
+          </a:prstGeom>
+          <a:noFill/>
+        </p:spPr>
+        <p:txBody>
+          <a:bodyPr wrap="none">
+            <a:spAutoFit/>
+          </a:bodyPr>
+          <a:lstStyle/>
+          <a:p>
+            <a:pPr algn="l"/>
+            <a:r>
+              <a:rPr sz="1400" b="0">
+                <a:solidFill>
+                  <a:srgbClr val="64748B"/>
+                </a:solidFill>
+                <a:latin typeface="Microsoft YaHei"/>
+                <a:ea typeface="Microsoft YaHei"/>
+              </a:rPr>
+              <a:t>主要收获：理清分层与接口；顺带踩过仿真时间同步</a:t>
+            </a:r>
+          </a:p>
+        </p:txBody>
+      </p:sp>
+      <p:sp>
+        <p:nvSpPr>
+          <p:cNvPr id="5" name="Rounded Rectangle 4"/>
+          <p:cNvSpPr/>
+          <p:nvPr/>
+        </p:nvSpPr>
+        <p:spPr>
+          <a:xfrm>
+            <a:off x="1828800" y="1234440"/>
+            <a:ext cx="4023360" cy="658368"/>
+          </a:xfrm>
+          <a:prstGeom prst="roundRect">
+            <a:avLst>
+              <a:gd name="adj" fmla="val 12000"/>
+            </a:avLst>
+          </a:prstGeom>
           <a:solidFill>
-            <a:srgbClr val="0F172A"/>
+            <a:srgbClr val="1E40AF"/>
           </a:solidFill>
           <a:ln>
             <a:noFill/>
@@ -3167,220 +3241,33 @@
           </a:fontRef>
         </p:style>
         <p:txBody>
-          <a:bodyPr rtlCol="0" anchor="ctr"/>
+          <a:bodyPr rtlCol="0" anchor="ctr" wrap="square"/>
           <a:lstStyle/>
           <a:p>
             <a:pPr algn="ctr"/>
-          </a:p>
-        </p:txBody>
-      </p:sp>
-      <p:sp>
-        <p:nvSpPr>
-          <p:cNvPr id="4" name="Rectangle 3"/>
-          <p:cNvSpPr/>
-          <p:nvPr/>
-        </p:nvSpPr>
-        <p:spPr>
-          <a:xfrm>
-            <a:off x="0" y="868680"/>
-            <a:ext cx="12191695" cy="54864"/>
-          </a:xfrm>
-          <a:prstGeom prst="rect">
-            <a:avLst/>
-          </a:prstGeom>
-          <a:solidFill>
-            <a:srgbClr val="1D4ED8"/>
-          </a:solidFill>
-          <a:ln>
-            <a:noFill/>
-          </a:ln>
-        </p:spPr>
-        <p:style>
-          <a:lnRef idx="1">
-            <a:schemeClr val="accent1"/>
-          </a:lnRef>
-          <a:fillRef idx="3">
-            <a:schemeClr val="accent1"/>
-          </a:fillRef>
-          <a:effectRef idx="2">
-            <a:schemeClr val="accent1"/>
-          </a:effectRef>
-          <a:fontRef idx="minor">
-            <a:schemeClr val="lt1"/>
-          </a:fontRef>
-        </p:style>
-        <p:txBody>
-          <a:bodyPr rtlCol="0" anchor="ctr"/>
-          <a:lstStyle/>
-          <a:p>
-            <a:pPr algn="ctr"/>
-          </a:p>
-        </p:txBody>
-      </p:sp>
-      <p:sp>
-        <p:nvSpPr>
-          <p:cNvPr id="5" name="TextBox 4"/>
-          <p:cNvSpPr txBox="1"/>
-          <p:nvPr/>
-        </p:nvSpPr>
-        <p:spPr>
-          <a:xfrm>
-            <a:off x="411480" y="164592"/>
-            <a:ext cx="10972800" cy="365760"/>
-          </a:xfrm>
-          <a:prstGeom prst="rect">
-            <a:avLst/>
-          </a:prstGeom>
-          <a:noFill/>
-        </p:spPr>
-        <p:txBody>
-          <a:bodyPr wrap="square">
-            <a:spAutoFit/>
-          </a:bodyPr>
-          <a:lstStyle/>
-          <a:p>
-            <a:pPr algn="l"/>
-            <a:r>
-              <a:rPr sz="2600" b="1">
+            <a:r>
+              <a:rPr sz="1800" b="1">
                 <a:solidFill>
                   <a:srgbClr val="FFFFFF"/>
                 </a:solidFill>
                 <a:latin typeface="Microsoft YaHei"/>
                 <a:ea typeface="Microsoft YaHei"/>
               </a:rPr>
-              <a:t>两轮自平衡车 · 软件分层框架总览</a:t>
-            </a:r>
-          </a:p>
-        </p:txBody>
-      </p:sp>
-      <p:sp>
-        <p:nvSpPr>
-          <p:cNvPr id="6" name="TextBox 5"/>
-          <p:cNvSpPr txBox="1"/>
-          <p:nvPr/>
-        </p:nvSpPr>
-        <p:spPr>
-          <a:xfrm>
-            <a:off x="411480" y="502920"/>
-            <a:ext cx="10972800" cy="274320"/>
-          </a:xfrm>
-          <a:prstGeom prst="rect">
-            <a:avLst/>
-          </a:prstGeom>
-          <a:noFill/>
-        </p:spPr>
-        <p:txBody>
-          <a:bodyPr wrap="square">
-            <a:spAutoFit/>
-          </a:bodyPr>
-          <a:lstStyle/>
-          <a:p>
-            <a:pPr algn="l"/>
-            <a:r>
-              <a:rPr sz="1200" b="0">
-                <a:solidFill>
-                  <a:srgbClr val="93C5FD"/>
-                </a:solidFill>
-                <a:latin typeface="Microsoft YaHei"/>
-                <a:ea typeface="Microsoft YaHei"/>
-              </a:rPr>
-              <a:t>SLAM / Nav2（上层）  →  /cmd_vel 接缝  →  本仓库运动与平衡底层（你改动的重点）</a:t>
-            </a:r>
-          </a:p>
-        </p:txBody>
-      </p:sp>
-      <p:sp>
-        <p:nvSpPr>
-          <p:cNvPr id="7" name="Rounded Rectangle 6"/>
+              <a:t>SLAM / Nav2</a:t>
+            </a:r>
+          </a:p>
+        </p:txBody>
+      </p:sp>
+      <p:sp>
+        <p:nvSpPr>
+          <p:cNvPr id="6" name="Down Arrow 5"/>
           <p:cNvSpPr/>
           <p:nvPr/>
         </p:nvSpPr>
         <p:spPr>
           <a:xfrm>
-            <a:off x="365760" y="1143000"/>
-            <a:ext cx="6583680" cy="713232"/>
-          </a:xfrm>
-          <a:prstGeom prst="roundRect">
-            <a:avLst>
-              <a:gd name="adj" fmla="val 8000"/>
-            </a:avLst>
-          </a:prstGeom>
-          <a:solidFill>
-            <a:srgbClr val="475569"/>
-          </a:solidFill>
-          <a:ln>
-            <a:noFill/>
-          </a:ln>
-        </p:spPr>
-        <p:style>
-          <a:lnRef idx="1">
-            <a:schemeClr val="accent1"/>
-          </a:lnRef>
-          <a:fillRef idx="3">
-            <a:schemeClr val="accent1"/>
-          </a:fillRef>
-          <a:effectRef idx="2">
-            <a:schemeClr val="accent1"/>
-          </a:effectRef>
-          <a:fontRef idx="minor">
-            <a:schemeClr val="lt1"/>
-          </a:fontRef>
-        </p:style>
-        <p:txBody>
-          <a:bodyPr rtlCol="0" anchor="ctr" wrap="square"/>
-          <a:lstStyle/>
-          <a:p>
-            <a:pPr algn="l">
-              <a:spcBef>
-                <a:spcPts val="100"/>
-              </a:spcBef>
-              <a:spcAft>
-                <a:spcPts val="100"/>
-              </a:spcAft>
-            </a:pPr>
-            <a:r>
-              <a:rPr sz="1500" b="1">
-                <a:solidFill>
-                  <a:srgbClr val="FFFFFF"/>
-                </a:solidFill>
-                <a:latin typeface="Microsoft YaHei"/>
-                <a:ea typeface="Microsoft YaHei"/>
-              </a:rPr>
-              <a:t>任务 / 应用层</a:t>
-            </a:r>
-          </a:p>
-          <a:p>
-            <a:pPr algn="l">
-              <a:spcBef>
-                <a:spcPts val="100"/>
-              </a:spcBef>
-              <a:spcAft>
-                <a:spcPts val="100"/>
-              </a:spcAft>
-            </a:pPr>
-            <a:r>
-              <a:rPr sz="1100" b="0">
-                <a:solidFill>
-                  <a:srgbClr val="E2E8F0"/>
-                </a:solidFill>
-                <a:latin typeface="Microsoft YaHei"/>
-                <a:ea typeface="Microsoft YaHei"/>
-              </a:rPr>
-              <a:t>多点巡航 · 任务编排 · 业务逻辑</a:t>
-            </a:r>
-          </a:p>
-        </p:txBody>
-      </p:sp>
-      <p:sp>
-        <p:nvSpPr>
-          <p:cNvPr id="8" name="Down Arrow 7"/>
-          <p:cNvSpPr/>
-          <p:nvPr/>
-        </p:nvSpPr>
-        <p:spPr>
-          <a:xfrm>
-            <a:off x="3429000" y="1865376"/>
-            <a:ext cx="164592" cy="82296"/>
+            <a:off x="3739896" y="1938528"/>
+            <a:ext cx="201168" cy="237744"/>
           </a:xfrm>
           <a:prstGeom prst="downArrow">
             <a:avLst/>
@@ -3416,22 +3303,22 @@
       </p:sp>
       <p:sp>
         <p:nvSpPr>
-          <p:cNvPr id="9" name="Rounded Rectangle 8"/>
+          <p:cNvPr id="7" name="Rounded Rectangle 6"/>
           <p:cNvSpPr/>
           <p:nvPr/>
         </p:nvSpPr>
         <p:spPr>
           <a:xfrm>
-            <a:off x="365760" y="1947672"/>
-            <a:ext cx="6583680" cy="713232"/>
+            <a:off x="1828800" y="2240280"/>
+            <a:ext cx="4023360" cy="658368"/>
           </a:xfrm>
           <a:prstGeom prst="roundRect">
             <a:avLst>
-              <a:gd name="adj" fmla="val 8000"/>
+              <a:gd name="adj" fmla="val 12000"/>
             </a:avLst>
           </a:prstGeom>
           <a:solidFill>
-            <a:srgbClr val="0F766E"/>
+            <a:srgbClr val="B45309"/>
           </a:solidFill>
           <a:ln>
             <a:noFill/>
@@ -3455,57 +3342,30 @@
           <a:bodyPr rtlCol="0" anchor="ctr" wrap="square"/>
           <a:lstStyle/>
           <a:p>
-            <a:pPr algn="l">
-              <a:spcBef>
-                <a:spcPts val="100"/>
-              </a:spcBef>
-              <a:spcAft>
-                <a:spcPts val="100"/>
-              </a:spcAft>
-            </a:pPr>
-            <a:r>
-              <a:rPr sz="1500" b="1">
+            <a:pPr algn="ctr"/>
+            <a:r>
+              <a:rPr sz="1800" b="1">
                 <a:solidFill>
                   <a:srgbClr val="FFFFFF"/>
                 </a:solidFill>
                 <a:latin typeface="Microsoft YaHei"/>
                 <a:ea typeface="Microsoft YaHei"/>
               </a:rPr>
-              <a:t>Nav2 导航规划层</a:t>
-            </a:r>
-          </a:p>
-          <a:p>
-            <a:pPr algn="l">
-              <a:spcBef>
-                <a:spcPts val="100"/>
-              </a:spcBef>
-              <a:spcAft>
-                <a:spcPts val="100"/>
-              </a:spcAft>
-            </a:pPr>
-            <a:r>
-              <a:rPr sz="1100" b="0">
-                <a:solidFill>
-                  <a:srgbClr val="E2E8F0"/>
-                </a:solidFill>
-                <a:latin typeface="Microsoft YaHei"/>
-                <a:ea typeface="Microsoft YaHei"/>
-              </a:rPr>
-              <a:t>BT Navigator · Planner · Controller · Costmap · Recovery</a:t>
-            </a:r>
-          </a:p>
-        </p:txBody>
-      </p:sp>
-      <p:sp>
-        <p:nvSpPr>
-          <p:cNvPr id="10" name="Down Arrow 9"/>
+              <a:t>/cmd_vel</a:t>
+            </a:r>
+          </a:p>
+        </p:txBody>
+      </p:sp>
+      <p:sp>
+        <p:nvSpPr>
+          <p:cNvPr id="8" name="Down Arrow 7"/>
           <p:cNvSpPr/>
           <p:nvPr/>
         </p:nvSpPr>
         <p:spPr>
           <a:xfrm>
-            <a:off x="3429000" y="2670048"/>
-            <a:ext cx="164592" cy="82296"/>
+            <a:off x="3739896" y="2944368"/>
+            <a:ext cx="201168" cy="237744"/>
           </a:xfrm>
           <a:prstGeom prst="downArrow">
             <a:avLst/>
@@ -3541,22 +3401,22 @@
       </p:sp>
       <p:sp>
         <p:nvSpPr>
-          <p:cNvPr id="11" name="Rounded Rectangle 10"/>
+          <p:cNvPr id="9" name="Rounded Rectangle 8"/>
           <p:cNvSpPr/>
           <p:nvPr/>
         </p:nvSpPr>
         <p:spPr>
           <a:xfrm>
-            <a:off x="365760" y="2752344"/>
-            <a:ext cx="6583680" cy="713232"/>
+            <a:off x="1828800" y="3246120"/>
+            <a:ext cx="4023360" cy="658368"/>
           </a:xfrm>
           <a:prstGeom prst="roundRect">
             <a:avLst>
-              <a:gd name="adj" fmla="val 8000"/>
+              <a:gd name="adj" fmla="val 12000"/>
             </a:avLst>
           </a:prstGeom>
           <a:solidFill>
-            <a:srgbClr val="1D4ED8"/>
+            <a:srgbClr val="B91C1C"/>
           </a:solidFill>
           <a:ln>
             <a:noFill/>
@@ -3580,57 +3440,30 @@
           <a:bodyPr rtlCol="0" anchor="ctr" wrap="square"/>
           <a:lstStyle/>
           <a:p>
-            <a:pPr algn="l">
-              <a:spcBef>
-                <a:spcPts val="100"/>
-              </a:spcBef>
-              <a:spcAft>
-                <a:spcPts val="100"/>
-              </a:spcAft>
-            </a:pPr>
-            <a:r>
-              <a:rPr sz="1500" b="1">
+            <a:pPr algn="ctr"/>
+            <a:r>
+              <a:rPr sz="1800" b="1">
                 <a:solidFill>
                   <a:srgbClr val="FFFFFF"/>
                 </a:solidFill>
                 <a:latin typeface="Microsoft YaHei"/>
                 <a:ea typeface="Microsoft YaHei"/>
               </a:rPr>
-              <a:t>SLAM 感知建图层</a:t>
-            </a:r>
-          </a:p>
-          <a:p>
-            <a:pPr algn="l">
-              <a:spcBef>
-                <a:spcPts val="100"/>
-              </a:spcBef>
-              <a:spcAft>
-                <a:spcPts val="100"/>
-              </a:spcAft>
-            </a:pPr>
-            <a:r>
-              <a:rPr sz="1100" b="0">
-                <a:solidFill>
-                  <a:srgbClr val="E2E8F0"/>
-                </a:solidFill>
-                <a:latin typeface="Microsoft YaHei"/>
-                <a:ea typeface="Microsoft YaHei"/>
-              </a:rPr>
-              <a:t>激光/视觉建图 · 定位 · map↔odom TF · /map</a:t>
-            </a:r>
-          </a:p>
-        </p:txBody>
-      </p:sp>
-      <p:sp>
-        <p:nvSpPr>
-          <p:cNvPr id="12" name="Down Arrow 11"/>
+              <a:t>平衡 · 速度 · 偏航</a:t>
+            </a:r>
+          </a:p>
+        </p:txBody>
+      </p:sp>
+      <p:sp>
+        <p:nvSpPr>
+          <p:cNvPr id="10" name="Down Arrow 9"/>
           <p:cNvSpPr/>
           <p:nvPr/>
         </p:nvSpPr>
         <p:spPr>
           <a:xfrm>
-            <a:off x="3429000" y="3474720"/>
-            <a:ext cx="164592" cy="82296"/>
+            <a:off x="3739896" y="3950208"/>
+            <a:ext cx="201168" cy="237744"/>
           </a:xfrm>
           <a:prstGeom prst="downArrow">
             <a:avLst/>
@@ -3666,22 +3499,22 @@
       </p:sp>
       <p:sp>
         <p:nvSpPr>
-          <p:cNvPr id="13" name="Rounded Rectangle 12"/>
+          <p:cNvPr id="11" name="Rounded Rectangle 10"/>
           <p:cNvSpPr/>
           <p:nvPr/>
         </p:nvSpPr>
         <p:spPr>
           <a:xfrm>
-            <a:off x="365760" y="3557016"/>
-            <a:ext cx="6583680" cy="713232"/>
+            <a:off x="1828800" y="4251960"/>
+            <a:ext cx="4023360" cy="658368"/>
           </a:xfrm>
           <a:prstGeom prst="roundRect">
             <a:avLst>
-              <a:gd name="adj" fmla="val 8000"/>
+              <a:gd name="adj" fmla="val 12000"/>
             </a:avLst>
           </a:prstGeom>
           <a:solidFill>
-            <a:srgbClr val="B45309"/>
+            <a:srgbClr val="334155"/>
           </a:solidFill>
           <a:ln>
             <a:noFill/>
@@ -3705,57 +3538,300 @@
           <a:bodyPr rtlCol="0" anchor="ctr" wrap="square"/>
           <a:lstStyle/>
           <a:p>
-            <a:pPr algn="l">
-              <a:spcBef>
-                <a:spcPts val="100"/>
-              </a:spcBef>
-              <a:spcAft>
-                <a:spcPts val="100"/>
-              </a:spcAft>
-            </a:pPr>
-            <a:r>
-              <a:rPr sz="1500" b="1">
+            <a:pPr algn="ctr"/>
+            <a:r>
+              <a:rPr sz="1800" b="1">
                 <a:solidFill>
                   <a:srgbClr val="FFFFFF"/>
                 </a:solidFill>
                 <a:latin typeface="Microsoft YaHei"/>
                 <a:ea typeface="Microsoft YaHei"/>
               </a:rPr>
-              <a:t>运动接口  /cmd_vel</a:t>
-            </a:r>
-          </a:p>
-          <a:p>
-            <a:pPr algn="l">
-              <a:spcBef>
-                <a:spcPts val="100"/>
-              </a:spcBef>
-              <a:spcAft>
-                <a:spcPts val="100"/>
-              </a:spcAft>
-            </a:pPr>
-            <a:r>
-              <a:rPr sz="1100" b="0">
+              <a:t>驱动 / 仿真</a:t>
+            </a:r>
+          </a:p>
+        </p:txBody>
+      </p:sp>
+      <p:sp>
+        <p:nvSpPr>
+          <p:cNvPr id="12" name="TextBox 11"/>
+          <p:cNvSpPr txBox="1"/>
+          <p:nvPr/>
+        </p:nvSpPr>
+        <p:spPr>
+          <a:xfrm>
+            <a:off x="6035040" y="2423160"/>
+            <a:ext cx="1645920" cy="365760"/>
+          </a:xfrm>
+          <a:prstGeom prst="rect">
+            <a:avLst/>
+          </a:prstGeom>
+          <a:noFill/>
+        </p:spPr>
+        <p:txBody>
+          <a:bodyPr wrap="none">
+            <a:spAutoFit/>
+          </a:bodyPr>
+          <a:lstStyle/>
+          <a:p>
+            <a:pPr algn="l"/>
+            <a:r>
+              <a:rPr sz="1300" b="1">
                 <a:solidFill>
-                  <a:srgbClr val="E2E8F0"/>
+                  <a:srgbClr val="B45309"/>
                 </a:solidFill>
                 <a:latin typeface="Microsoft YaHei"/>
                 <a:ea typeface="Microsoft YaHei"/>
               </a:rPr>
-              <a:t>geometry_msgs/Twist{v, ω}  —— 行业标准接缝</a:t>
-            </a:r>
-          </a:p>
-        </p:txBody>
-      </p:sp>
-      <p:sp>
-        <p:nvSpPr>
-          <p:cNvPr id="14" name="Down Arrow 13"/>
+              <a:t>← 接缝</a:t>
+            </a:r>
+          </a:p>
+        </p:txBody>
+      </p:sp>
+      <p:cxnSp>
+        <p:nvCxnSpPr>
+          <p:cNvPr id="13" name="Connector 12"/>
+          <p:cNvCxnSpPr/>
+          <p:nvPr/>
+        </p:nvCxnSpPr>
+        <p:spPr>
+          <a:xfrm>
+            <a:off x="1508760.0" y="3246120"/>
+            <a:ext cx="0.0" cy="1664208"/>
+          </a:xfrm>
+          <a:prstGeom prst="line">
+            <a:avLst/>
+          </a:prstGeom>
+          <a:ln w="31750">
+            <a:solidFill>
+              <a:srgbClr val="B91C1C"/>
+            </a:solidFill>
+          </a:ln>
+        </p:spPr>
+        <p:style>
+          <a:lnRef idx="2">
+            <a:schemeClr val="accent1"/>
+          </a:lnRef>
+          <a:fillRef idx="0">
+            <a:schemeClr val="accent1"/>
+          </a:fillRef>
+          <a:effectRef idx="1">
+            <a:schemeClr val="accent1"/>
+          </a:effectRef>
+          <a:fontRef idx="minor">
+            <a:schemeClr val="tx1"/>
+          </a:fontRef>
+        </p:style>
+      </p:cxnSp>
+      <p:cxnSp>
+        <p:nvCxnSpPr>
+          <p:cNvPr id="14" name="Connector 13"/>
+          <p:cNvCxnSpPr/>
+          <p:nvPr/>
+        </p:nvCxnSpPr>
+        <p:spPr>
+          <a:xfrm>
+            <a:off x="1508760.0" y="3246120"/>
+            <a:ext cx="228600.0" cy="0"/>
+          </a:xfrm>
+          <a:prstGeom prst="line">
+            <a:avLst/>
+          </a:prstGeom>
+          <a:ln w="31750">
+            <a:solidFill>
+              <a:srgbClr val="B91C1C"/>
+            </a:solidFill>
+          </a:ln>
+        </p:spPr>
+        <p:style>
+          <a:lnRef idx="2">
+            <a:schemeClr val="accent1"/>
+          </a:lnRef>
+          <a:fillRef idx="0">
+            <a:schemeClr val="accent1"/>
+          </a:fillRef>
+          <a:effectRef idx="1">
+            <a:schemeClr val="accent1"/>
+          </a:effectRef>
+          <a:fontRef idx="minor">
+            <a:schemeClr val="tx1"/>
+          </a:fontRef>
+        </p:style>
+      </p:cxnSp>
+      <p:cxnSp>
+        <p:nvCxnSpPr>
+          <p:cNvPr id="15" name="Connector 14"/>
+          <p:cNvCxnSpPr/>
+          <p:nvPr/>
+        </p:nvCxnSpPr>
+        <p:spPr>
+          <a:xfrm>
+            <a:off x="1508760.0" y="4910328"/>
+            <a:ext cx="228600.0" cy="0"/>
+          </a:xfrm>
+          <a:prstGeom prst="line">
+            <a:avLst/>
+          </a:prstGeom>
+          <a:ln w="31750">
+            <a:solidFill>
+              <a:srgbClr val="B91C1C"/>
+            </a:solidFill>
+          </a:ln>
+        </p:spPr>
+        <p:style>
+          <a:lnRef idx="2">
+            <a:schemeClr val="accent1"/>
+          </a:lnRef>
+          <a:fillRef idx="0">
+            <a:schemeClr val="accent1"/>
+          </a:fillRef>
+          <a:effectRef idx="1">
+            <a:schemeClr val="accent1"/>
+          </a:effectRef>
+          <a:fontRef idx="minor">
+            <a:schemeClr val="tx1"/>
+          </a:fontRef>
+        </p:style>
+      </p:cxnSp>
+      <p:sp>
+        <p:nvSpPr>
+          <p:cNvPr id="16" name="TextBox 15"/>
+          <p:cNvSpPr txBox="1"/>
+          <p:nvPr/>
+        </p:nvSpPr>
+        <p:spPr>
+          <a:xfrm>
+            <a:off x="320040" y="3749040"/>
+            <a:ext cx="1280160" cy="457200"/>
+          </a:xfrm>
+          <a:prstGeom prst="rect">
+            <a:avLst/>
+          </a:prstGeom>
+          <a:noFill/>
+        </p:spPr>
+        <p:txBody>
+          <a:bodyPr wrap="none">
+            <a:spAutoFit/>
+          </a:bodyPr>
+          <a:lstStyle/>
+          <a:p>
+            <a:pPr algn="ctr"/>
+            <a:r>
+              <a:rPr sz="1300" b="1">
+                <a:solidFill>
+                  <a:srgbClr val="B91C1C"/>
+                </a:solidFill>
+                <a:latin typeface="Microsoft YaHei"/>
+                <a:ea typeface="Microsoft YaHei"/>
+              </a:rPr>
+              <a:t>本仓库</a:t>
+            </a:r>
+          </a:p>
+        </p:txBody>
+      </p:sp>
+      <p:sp>
+        <p:nvSpPr>
+          <p:cNvPr id="17" name="TextBox 16"/>
+          <p:cNvSpPr txBox="1"/>
+          <p:nvPr/>
+        </p:nvSpPr>
+        <p:spPr>
+          <a:xfrm>
+            <a:off x="7589520" y="1234440"/>
+            <a:ext cx="4114800" cy="320040"/>
+          </a:xfrm>
+          <a:prstGeom prst="rect">
+            <a:avLst/>
+          </a:prstGeom>
+          <a:noFill/>
+        </p:spPr>
+        <p:txBody>
+          <a:bodyPr wrap="none">
+            <a:spAutoFit/>
+          </a:bodyPr>
+          <a:lstStyle/>
+          <a:p>
+            <a:pPr algn="l"/>
+            <a:r>
+              <a:rPr sz="1600" b="1">
+                <a:solidFill>
+                  <a:srgbClr val="0F172A"/>
+                </a:solidFill>
+                <a:latin typeface="Microsoft YaHei"/>
+                <a:ea typeface="Microsoft YaHei"/>
+              </a:rPr>
+              <a:t>时间同步</a:t>
+            </a:r>
+          </a:p>
+        </p:txBody>
+      </p:sp>
+      <p:sp>
+        <p:nvSpPr>
+          <p:cNvPr id="18" name="Rounded Rectangle 17"/>
           <p:cNvSpPr/>
           <p:nvPr/>
         </p:nvSpPr>
         <p:spPr>
           <a:xfrm>
-            <a:off x="3429000" y="4279392"/>
-            <a:ext cx="164592" cy="82296"/>
+            <a:off x="7589520" y="1737360"/>
+            <a:ext cx="3931920" cy="777240"/>
+          </a:xfrm>
+          <a:prstGeom prst="roundRect">
+            <a:avLst>
+              <a:gd name="adj" fmla="val 12000"/>
+            </a:avLst>
+          </a:prstGeom>
+          <a:solidFill>
+            <a:srgbClr val="FFFFFF"/>
+          </a:solidFill>
+          <a:ln w="19050">
+            <a:solidFill>
+              <a:srgbClr val="BFDBFE"/>
+            </a:solidFill>
+          </a:ln>
+        </p:spPr>
+        <p:style>
+          <a:lnRef idx="1">
+            <a:schemeClr val="accent1"/>
+          </a:lnRef>
+          <a:fillRef idx="3">
+            <a:schemeClr val="accent1"/>
+          </a:fillRef>
+          <a:effectRef idx="2">
+            <a:schemeClr val="accent1"/>
+          </a:effectRef>
+          <a:fontRef idx="minor">
+            <a:schemeClr val="lt1"/>
+          </a:fontRef>
+        </p:style>
+        <p:txBody>
+          <a:bodyPr rtlCol="0" anchor="ctr" wrap="square"/>
+          <a:lstStyle/>
+          <a:p>
+            <a:pPr algn="ctr"/>
+            <a:r>
+              <a:rPr sz="1600" b="1">
+                <a:solidFill>
+                  <a:srgbClr val="1E40AF"/>
+                </a:solidFill>
+                <a:latin typeface="Microsoft YaHei"/>
+                <a:ea typeface="Microsoft YaHei"/>
+              </a:rPr>
+              <a:t>Gazebo  /clock</a:t>
+            </a:r>
+          </a:p>
+        </p:txBody>
+      </p:sp>
+      <p:sp>
+        <p:nvSpPr>
+          <p:cNvPr id="19" name="Down Arrow 18"/>
+          <p:cNvSpPr/>
+          <p:nvPr/>
+        </p:nvSpPr>
+        <p:spPr>
+          <a:xfrm>
+            <a:off x="9454896" y="2606040"/>
+            <a:ext cx="201168" cy="256032"/>
           </a:xfrm>
           <a:prstGeom prst="downArrow">
             <a:avLst/>
@@ -3791,25 +3867,27 @@
       </p:sp>
       <p:sp>
         <p:nvSpPr>
-          <p:cNvPr id="15" name="Rounded Rectangle 14"/>
+          <p:cNvPr id="20" name="Rounded Rectangle 19"/>
           <p:cNvSpPr/>
           <p:nvPr/>
         </p:nvSpPr>
         <p:spPr>
           <a:xfrm>
-            <a:off x="365760" y="4361688"/>
-            <a:ext cx="6583680" cy="713232"/>
+            <a:off x="7589520" y="2971800"/>
+            <a:ext cx="1828800" cy="1005840"/>
           </a:xfrm>
           <a:prstGeom prst="roundRect">
             <a:avLst>
-              <a:gd name="adj" fmla="val 8000"/>
+              <a:gd name="adj" fmla="val 12000"/>
             </a:avLst>
           </a:prstGeom>
           <a:solidFill>
-            <a:srgbClr val="C2410C"/>
+            <a:srgbClr val="EFF6FF"/>
           </a:solidFill>
-          <a:ln>
-            <a:noFill/>
+          <a:ln w="19050">
+            <a:solidFill>
+              <a:srgbClr val="93C5FD"/>
+            </a:solidFill>
           </a:ln>
         </p:spPr>
         <p:style>
@@ -3830,1005 +3908,237 @@
           <a:bodyPr rtlCol="0" anchor="ctr" wrap="square"/>
           <a:lstStyle/>
           <a:p>
-            <a:pPr algn="l">
-              <a:spcBef>
-                <a:spcPts val="100"/>
-              </a:spcBef>
-              <a:spcAft>
-                <a:spcPts val="100"/>
-              </a:spcAft>
-            </a:pPr>
-            <a:r>
-              <a:rPr sz="1500" b="1">
-                <a:solidFill>
-                  <a:srgbClr val="FFFFFF"/>
-                </a:solidFill>
-                <a:latin typeface="Microsoft YaHei"/>
-                <a:ea typeface="Microsoft YaHei"/>
-              </a:rPr>
-              <a:t>★ 本仓库重点：运动与平衡底层</a:t>
-            </a:r>
-          </a:p>
-          <a:p>
-            <a:pPr algn="l">
-              <a:spcBef>
-                <a:spcPts val="100"/>
-              </a:spcBef>
-              <a:spcAft>
-                <a:spcPts val="100"/>
-              </a:spcAft>
-            </a:pPr>
-            <a:r>
-              <a:rPr sz="1100" b="0">
-                <a:solidFill>
-                  <a:srgbClr val="E2E8F0"/>
-                </a:solidFill>
-                <a:latin typeface="Microsoft YaHei"/>
-                <a:ea typeface="Microsoft YaHei"/>
-              </a:rPr>
-              <a:t>MotionAdapter · Position/Velocity · Yaw(+航向保持) · Mixer · Safety</a:t>
-            </a:r>
-          </a:p>
-        </p:txBody>
-      </p:sp>
-      <p:sp>
-        <p:nvSpPr>
-          <p:cNvPr id="16" name="Rectangle 15"/>
-          <p:cNvSpPr/>
-          <p:nvPr/>
-        </p:nvSpPr>
-        <p:spPr>
-          <a:xfrm>
-            <a:off x="365760" y="4361688"/>
-            <a:ext cx="109728" cy="713232"/>
-          </a:xfrm>
-          <a:prstGeom prst="rect">
-            <a:avLst/>
-          </a:prstGeom>
-          <a:solidFill>
-            <a:srgbClr val="FEF3C7"/>
-          </a:solidFill>
-          <a:ln>
-            <a:noFill/>
-          </a:ln>
-        </p:spPr>
-        <p:style>
-          <a:lnRef idx="1">
-            <a:schemeClr val="accent1"/>
-          </a:lnRef>
-          <a:fillRef idx="3">
-            <a:schemeClr val="accent1"/>
-          </a:fillRef>
-          <a:effectRef idx="2">
-            <a:schemeClr val="accent1"/>
-          </a:effectRef>
-          <a:fontRef idx="minor">
-            <a:schemeClr val="lt1"/>
-          </a:fontRef>
-        </p:style>
-        <p:txBody>
-          <a:bodyPr rtlCol="0" anchor="ctr"/>
-          <a:lstStyle/>
-          <a:p>
             <a:pPr algn="ctr"/>
-          </a:p>
-        </p:txBody>
-      </p:sp>
-      <p:sp>
-        <p:nvSpPr>
-          <p:cNvPr id="17" name="Down Arrow 16"/>
-          <p:cNvSpPr/>
-          <p:nvPr/>
-        </p:nvSpPr>
-        <p:spPr>
-          <a:xfrm>
-            <a:off x="3429000" y="5084064"/>
-            <a:ext cx="164592" cy="82296"/>
-          </a:xfrm>
-          <a:prstGeom prst="downArrow">
-            <a:avLst/>
-          </a:prstGeom>
-          <a:solidFill>
-            <a:srgbClr val="94A3B8"/>
-          </a:solidFill>
-          <a:ln>
-            <a:noFill/>
-          </a:ln>
-        </p:spPr>
-        <p:style>
-          <a:lnRef idx="1">
-            <a:schemeClr val="accent1"/>
-          </a:lnRef>
-          <a:fillRef idx="3">
-            <a:schemeClr val="accent1"/>
-          </a:fillRef>
-          <a:effectRef idx="2">
-            <a:schemeClr val="accent1"/>
-          </a:effectRef>
-          <a:fontRef idx="minor">
-            <a:schemeClr val="lt1"/>
-          </a:fontRef>
-        </p:style>
-        <p:txBody>
-          <a:bodyPr rtlCol="0" anchor="ctr"/>
-          <a:lstStyle/>
-          <a:p>
-            <a:pPr algn="ctr"/>
-          </a:p>
-        </p:txBody>
-      </p:sp>
-      <p:sp>
-        <p:nvSpPr>
-          <p:cNvPr id="18" name="Rounded Rectangle 17"/>
-          <p:cNvSpPr/>
-          <p:nvPr/>
-        </p:nvSpPr>
-        <p:spPr>
-          <a:xfrm>
-            <a:off x="365760" y="5166360"/>
-            <a:ext cx="6583680" cy="713232"/>
-          </a:xfrm>
-          <a:prstGeom prst="roundRect">
-            <a:avLst>
-              <a:gd name="adj" fmla="val 8000"/>
-            </a:avLst>
-          </a:prstGeom>
-          <a:solidFill>
-            <a:srgbClr val="334155"/>
-          </a:solidFill>
-          <a:ln>
-            <a:noFill/>
-          </a:ln>
-        </p:spPr>
-        <p:style>
-          <a:lnRef idx="1">
-            <a:schemeClr val="accent1"/>
-          </a:lnRef>
-          <a:fillRef idx="3">
-            <a:schemeClr val="accent1"/>
-          </a:fillRef>
-          <a:effectRef idx="2">
-            <a:schemeClr val="accent1"/>
-          </a:effectRef>
-          <a:fontRef idx="minor">
-            <a:schemeClr val="lt1"/>
-          </a:fontRef>
-        </p:style>
-        <p:txBody>
-          <a:bodyPr rtlCol="0" anchor="ctr" wrap="square"/>
-          <a:lstStyle/>
-          <a:p>
-            <a:pPr algn="l">
-              <a:spcBef>
-                <a:spcPts val="100"/>
-              </a:spcBef>
-              <a:spcAft>
-                <a:spcPts val="100"/>
-              </a:spcAft>
-            </a:pPr>
-            <a:r>
-              <a:rPr sz="1500" b="1">
-                <a:solidFill>
-                  <a:srgbClr val="FFFFFF"/>
-                </a:solidFill>
-                <a:latin typeface="Microsoft YaHei"/>
-                <a:ea typeface="Microsoft YaHei"/>
-              </a:rPr>
-              <a:t>驱动与仿真层</a:t>
-            </a:r>
-          </a:p>
-          <a:p>
-            <a:pPr algn="l">
-              <a:spcBef>
-                <a:spcPts val="100"/>
-              </a:spcBef>
-              <a:spcAft>
-                <a:spcPts val="100"/>
-              </a:spcAft>
-            </a:pPr>
-            <a:r>
-              <a:rPr sz="1100" b="0">
-                <a:solidFill>
-                  <a:srgbClr val="E2E8F0"/>
-                </a:solidFill>
-                <a:latin typeface="Microsoft YaHei"/>
-                <a:ea typeface="Microsoft YaHei"/>
-              </a:rPr>
-              <a:t>ros2_control · Gazebo · IMU · 轮关节力矩</a:t>
-            </a:r>
-          </a:p>
-        </p:txBody>
-      </p:sp>
-      <p:sp>
-        <p:nvSpPr>
-          <p:cNvPr id="19" name="Rounded Rectangle 18"/>
-          <p:cNvSpPr/>
-          <p:nvPr/>
-        </p:nvSpPr>
-        <p:spPr>
-          <a:xfrm>
-            <a:off x="7178040" y="1143000"/>
-            <a:ext cx="4617720" cy="4892040"/>
-          </a:xfrm>
-          <a:prstGeom prst="roundRect">
-            <a:avLst>
-              <a:gd name="adj" fmla="val 8000"/>
-            </a:avLst>
-          </a:prstGeom>
-          <a:solidFill>
-            <a:srgbClr val="FFFFFF"/>
-          </a:solidFill>
-          <a:ln w="15875">
-            <a:solidFill>
-              <a:srgbClr val="D8DEE9"/>
-            </a:solidFill>
-          </a:ln>
-        </p:spPr>
-        <p:style>
-          <a:lnRef idx="1">
-            <a:schemeClr val="accent1"/>
-          </a:lnRef>
-          <a:fillRef idx="3">
-            <a:schemeClr val="accent1"/>
-          </a:fillRef>
-          <a:effectRef idx="2">
-            <a:schemeClr val="accent1"/>
-          </a:effectRef>
-          <a:fontRef idx="minor">
-            <a:schemeClr val="lt1"/>
-          </a:fontRef>
-        </p:style>
-        <p:txBody>
-          <a:bodyPr rtlCol="0" anchor="ctr"/>
-          <a:lstStyle/>
-          <a:p>
-            <a:pPr algn="ctr"/>
-          </a:p>
-        </p:txBody>
-      </p:sp>
-      <p:sp>
-        <p:nvSpPr>
-          <p:cNvPr id="20" name="TextBox 19"/>
-          <p:cNvSpPr txBox="1"/>
-          <p:nvPr/>
-        </p:nvSpPr>
-        <p:spPr>
-          <a:xfrm>
-            <a:off x="7360920" y="1234440"/>
-            <a:ext cx="4206240" cy="320040"/>
-          </a:xfrm>
-          <a:prstGeom prst="rect">
-            <a:avLst/>
-          </a:prstGeom>
-          <a:noFill/>
-        </p:spPr>
-        <p:txBody>
-          <a:bodyPr wrap="square">
-            <a:spAutoFit/>
-          </a:bodyPr>
-          <a:lstStyle/>
-          <a:p>
-            <a:pPr algn="l"/>
-            <a:r>
-              <a:rPr sz="1400" b="1">
-                <a:solidFill>
-                  <a:srgbClr val="0F172A"/>
-                </a:solidFill>
-                <a:latin typeface="Microsoft YaHei"/>
-                <a:ea typeface="Microsoft YaHei"/>
-              </a:rPr>
-              <a:t>本仓库内部数据流（面试重点）</a:t>
-            </a:r>
-          </a:p>
-        </p:txBody>
-      </p:sp>
-      <p:sp>
-        <p:nvSpPr>
-          <p:cNvPr id="21" name="Rounded Rectangle 20"/>
-          <p:cNvSpPr/>
-          <p:nvPr/>
-        </p:nvSpPr>
-        <p:spPr>
-          <a:xfrm>
-            <a:off x="7406640" y="1691640"/>
-            <a:ext cx="4206240" cy="566928"/>
-          </a:xfrm>
-          <a:prstGeom prst="roundRect">
-            <a:avLst>
-              <a:gd name="adj" fmla="val 8000"/>
-            </a:avLst>
-          </a:prstGeom>
-          <a:solidFill>
-            <a:srgbClr val="0F172A"/>
-          </a:solidFill>
-          <a:ln>
-            <a:noFill/>
-          </a:ln>
-        </p:spPr>
-        <p:style>
-          <a:lnRef idx="1">
-            <a:schemeClr val="accent1"/>
-          </a:lnRef>
-          <a:fillRef idx="3">
-            <a:schemeClr val="accent1"/>
-          </a:fillRef>
-          <a:effectRef idx="2">
-            <a:schemeClr val="accent1"/>
-          </a:effectRef>
-          <a:fontRef idx="minor">
-            <a:schemeClr val="lt1"/>
-          </a:fontRef>
-        </p:style>
-        <p:txBody>
-          <a:bodyPr rtlCol="0" anchor="ctr" wrap="square"/>
-          <a:lstStyle/>
-          <a:p>
-            <a:pPr algn="ctr">
-              <a:spcBef>
-                <a:spcPts val="100"/>
-              </a:spcBef>
-              <a:spcAft>
-                <a:spcPts val="100"/>
-              </a:spcAft>
-            </a:pPr>
-            <a:r>
-              <a:rPr sz="1200" b="1">
-                <a:solidFill>
-                  <a:srgbClr val="FFFFFF"/>
-                </a:solidFill>
-                <a:latin typeface="Microsoft YaHei"/>
-                <a:ea typeface="Microsoft YaHei"/>
-              </a:rPr>
-              <a:t>/cmd_vel  Twist</a:t>
-            </a:r>
-          </a:p>
-        </p:txBody>
-      </p:sp>
-      <p:sp>
-        <p:nvSpPr>
-          <p:cNvPr id="22" name="Down Arrow 21"/>
-          <p:cNvSpPr/>
-          <p:nvPr/>
-        </p:nvSpPr>
-        <p:spPr>
-          <a:xfrm>
-            <a:off x="9326880" y="2267712"/>
-            <a:ext cx="146304" cy="73152"/>
-          </a:xfrm>
-          <a:prstGeom prst="downArrow">
-            <a:avLst/>
-          </a:prstGeom>
-          <a:solidFill>
-            <a:srgbClr val="94A3B8"/>
-          </a:solidFill>
-          <a:ln>
-            <a:noFill/>
-          </a:ln>
-        </p:spPr>
-        <p:style>
-          <a:lnRef idx="1">
-            <a:schemeClr val="accent1"/>
-          </a:lnRef>
-          <a:fillRef idx="3">
-            <a:schemeClr val="accent1"/>
-          </a:fillRef>
-          <a:effectRef idx="2">
-            <a:schemeClr val="accent1"/>
-          </a:effectRef>
-          <a:fontRef idx="minor">
-            <a:schemeClr val="lt1"/>
-          </a:fontRef>
-        </p:style>
-        <p:txBody>
-          <a:bodyPr rtlCol="0" anchor="ctr"/>
-          <a:lstStyle/>
-          <a:p>
-            <a:pPr algn="ctr"/>
-          </a:p>
-        </p:txBody>
-      </p:sp>
-      <p:sp>
-        <p:nvSpPr>
-          <p:cNvPr id="23" name="Rounded Rectangle 22"/>
-          <p:cNvSpPr/>
-          <p:nvPr/>
-        </p:nvSpPr>
-        <p:spPr>
-          <a:xfrm>
-            <a:off x="7406640" y="2350008"/>
-            <a:ext cx="4206240" cy="566928"/>
-          </a:xfrm>
-          <a:prstGeom prst="roundRect">
-            <a:avLst>
-              <a:gd name="adj" fmla="val 8000"/>
-            </a:avLst>
-          </a:prstGeom>
-          <a:solidFill>
-            <a:srgbClr val="1D4ED8"/>
-          </a:solidFill>
-          <a:ln>
-            <a:noFill/>
-          </a:ln>
-        </p:spPr>
-        <p:style>
-          <a:lnRef idx="1">
-            <a:schemeClr val="accent1"/>
-          </a:lnRef>
-          <a:fillRef idx="3">
-            <a:schemeClr val="accent1"/>
-          </a:fillRef>
-          <a:effectRef idx="2">
-            <a:schemeClr val="accent1"/>
-          </a:effectRef>
-          <a:fontRef idx="minor">
-            <a:schemeClr val="lt1"/>
-          </a:fontRef>
-        </p:style>
-        <p:txBody>
-          <a:bodyPr rtlCol="0" anchor="ctr" wrap="square"/>
-          <a:lstStyle/>
-          <a:p>
-            <a:pPr algn="ctr">
-              <a:spcBef>
-                <a:spcPts val="100"/>
-              </a:spcBef>
-              <a:spcAft>
-                <a:spcPts val="100"/>
-              </a:spcAft>
-            </a:pPr>
-            <a:r>
-              <a:rPr sz="1200" b="1">
-                <a:solidFill>
-                  <a:srgbClr val="FFFFFF"/>
-                </a:solidFill>
-                <a:latin typeface="Microsoft YaHei"/>
-                <a:ea typeface="Microsoft YaHei"/>
-              </a:rPr>
-              <a:t>MotionCommandAdapter</a:t>
-            </a:r>
-          </a:p>
-          <a:p>
-            <a:pPr algn="ctr">
-              <a:spcBef>
-                <a:spcPts val="100"/>
-              </a:spcBef>
-              <a:spcAft>
-                <a:spcPts val="100"/>
-              </a:spcAft>
-            </a:pPr>
-            <a:r>
-              <a:rPr sz="1000" b="0">
-                <a:solidFill>
-                  <a:srgbClr val="E2E8F0"/>
-                </a:solidFill>
-                <a:latin typeface="Microsoft YaHei"/>
-                <a:ea typeface="Microsoft YaHei"/>
-              </a:rPr>
-              <a:t>限幅 · 换算 · 超时归零</a:t>
-            </a:r>
-          </a:p>
-        </p:txBody>
-      </p:sp>
-      <p:sp>
-        <p:nvSpPr>
-          <p:cNvPr id="24" name="Down Arrow 23"/>
-          <p:cNvSpPr/>
-          <p:nvPr/>
-        </p:nvSpPr>
-        <p:spPr>
-          <a:xfrm>
-            <a:off x="9326880" y="2926080"/>
-            <a:ext cx="146304" cy="73152"/>
-          </a:xfrm>
-          <a:prstGeom prst="downArrow">
-            <a:avLst/>
-          </a:prstGeom>
-          <a:solidFill>
-            <a:srgbClr val="94A3B8"/>
-          </a:solidFill>
-          <a:ln>
-            <a:noFill/>
-          </a:ln>
-        </p:spPr>
-        <p:style>
-          <a:lnRef idx="1">
-            <a:schemeClr val="accent1"/>
-          </a:lnRef>
-          <a:fillRef idx="3">
-            <a:schemeClr val="accent1"/>
-          </a:fillRef>
-          <a:effectRef idx="2">
-            <a:schemeClr val="accent1"/>
-          </a:effectRef>
-          <a:fontRef idx="minor">
-            <a:schemeClr val="lt1"/>
-          </a:fontRef>
-        </p:style>
-        <p:txBody>
-          <a:bodyPr rtlCol="0" anchor="ctr"/>
-          <a:lstStyle/>
-          <a:p>
-            <a:pPr algn="ctr"/>
-          </a:p>
-        </p:txBody>
-      </p:sp>
-      <p:sp>
-        <p:nvSpPr>
-          <p:cNvPr id="25" name="Rounded Rectangle 24"/>
-          <p:cNvSpPr/>
-          <p:nvPr/>
-        </p:nvSpPr>
-        <p:spPr>
-          <a:xfrm>
-            <a:off x="7406640" y="3008376"/>
-            <a:ext cx="4206240" cy="566928"/>
-          </a:xfrm>
-          <a:prstGeom prst="roundRect">
-            <a:avLst>
-              <a:gd name="adj" fmla="val 8000"/>
-            </a:avLst>
-          </a:prstGeom>
-          <a:solidFill>
-            <a:srgbClr val="0F766E"/>
-          </a:solidFill>
-          <a:ln>
-            <a:noFill/>
-          </a:ln>
-        </p:spPr>
-        <p:style>
-          <a:lnRef idx="1">
-            <a:schemeClr val="accent1"/>
-          </a:lnRef>
-          <a:fillRef idx="3">
-            <a:schemeClr val="accent1"/>
-          </a:fillRef>
-          <a:effectRef idx="2">
-            <a:schemeClr val="accent1"/>
-          </a:effectRef>
-          <a:fontRef idx="minor">
-            <a:schemeClr val="lt1"/>
-          </a:fontRef>
-        </p:style>
-        <p:txBody>
-          <a:bodyPr rtlCol="0" anchor="ctr" wrap="square"/>
-          <a:lstStyle/>
-          <a:p>
-            <a:pPr algn="ctr">
-              <a:spcBef>
-                <a:spcPts val="100"/>
-              </a:spcBef>
-              <a:spcAft>
-                <a:spcPts val="100"/>
-              </a:spcAft>
-            </a:pPr>
-            <a:r>
-              <a:rPr sz="1200" b="1">
-                <a:solidFill>
-                  <a:srgbClr val="FFFFFF"/>
-                </a:solidFill>
-                <a:latin typeface="Microsoft YaHei"/>
-                <a:ea typeface="Microsoft YaHei"/>
-              </a:rPr>
-              <a:t>Position/VelocityLoop  |  YawLoop</a:t>
-            </a:r>
-          </a:p>
-          <a:p>
-            <a:pPr algn="ctr">
-              <a:spcBef>
-                <a:spcPts val="100"/>
-              </a:spcBef>
-              <a:spcAft>
-                <a:spcPts val="100"/>
-              </a:spcAft>
-            </a:pPr>
-            <a:r>
-              <a:rPr sz="1000" b="0">
-                <a:solidFill>
-                  <a:srgbClr val="E2E8F0"/>
-                </a:solidFill>
-                <a:latin typeface="Microsoft YaHei"/>
-                <a:ea typeface="Microsoft YaHei"/>
-              </a:rPr>
-              <a:t>速度/位置通道          转向+航向保持</a:t>
-            </a:r>
-          </a:p>
-        </p:txBody>
-      </p:sp>
-      <p:sp>
-        <p:nvSpPr>
-          <p:cNvPr id="26" name="Down Arrow 25"/>
-          <p:cNvSpPr/>
-          <p:nvPr/>
-        </p:nvSpPr>
-        <p:spPr>
-          <a:xfrm>
-            <a:off x="9326880" y="3584448"/>
-            <a:ext cx="146304" cy="73152"/>
-          </a:xfrm>
-          <a:prstGeom prst="downArrow">
-            <a:avLst/>
-          </a:prstGeom>
-          <a:solidFill>
-            <a:srgbClr val="94A3B8"/>
-          </a:solidFill>
-          <a:ln>
-            <a:noFill/>
-          </a:ln>
-        </p:spPr>
-        <p:style>
-          <a:lnRef idx="1">
-            <a:schemeClr val="accent1"/>
-          </a:lnRef>
-          <a:fillRef idx="3">
-            <a:schemeClr val="accent1"/>
-          </a:fillRef>
-          <a:effectRef idx="2">
-            <a:schemeClr val="accent1"/>
-          </a:effectRef>
-          <a:fontRef idx="minor">
-            <a:schemeClr val="lt1"/>
-          </a:fontRef>
-        </p:style>
-        <p:txBody>
-          <a:bodyPr rtlCol="0" anchor="ctr"/>
-          <a:lstStyle/>
-          <a:p>
-            <a:pPr algn="ctr"/>
-          </a:p>
-        </p:txBody>
-      </p:sp>
-      <p:sp>
-        <p:nvSpPr>
-          <p:cNvPr id="27" name="Rounded Rectangle 26"/>
-          <p:cNvSpPr/>
-          <p:nvPr/>
-        </p:nvSpPr>
-        <p:spPr>
-          <a:xfrm>
-            <a:off x="7406640" y="3666744"/>
-            <a:ext cx="4206240" cy="566928"/>
-          </a:xfrm>
-          <a:prstGeom prst="roundRect">
-            <a:avLst>
-              <a:gd name="adj" fmla="val 8000"/>
-            </a:avLst>
-          </a:prstGeom>
-          <a:solidFill>
-            <a:srgbClr val="B45309"/>
-          </a:solidFill>
-          <a:ln>
-            <a:noFill/>
-          </a:ln>
-        </p:spPr>
-        <p:style>
-          <a:lnRef idx="1">
-            <a:schemeClr val="accent1"/>
-          </a:lnRef>
-          <a:fillRef idx="3">
-            <a:schemeClr val="accent1"/>
-          </a:fillRef>
-          <a:effectRef idx="2">
-            <a:schemeClr val="accent1"/>
-          </a:effectRef>
-          <a:fontRef idx="minor">
-            <a:schemeClr val="lt1"/>
-          </a:fontRef>
-        </p:style>
-        <p:txBody>
-          <a:bodyPr rtlCol="0" anchor="ctr" wrap="square"/>
-          <a:lstStyle/>
-          <a:p>
-            <a:pPr algn="ctr">
-              <a:spcBef>
-                <a:spcPts val="100"/>
-              </a:spcBef>
-              <a:spcAft>
-                <a:spcPts val="100"/>
-              </a:spcAft>
-            </a:pPr>
-            <a:r>
-              <a:rPr sz="1200" b="1">
-                <a:solidFill>
-                  <a:srgbClr val="FFFFFF"/>
-                </a:solidFill>
-                <a:latin typeface="Microsoft YaHei"/>
-                <a:ea typeface="Microsoft YaHei"/>
-              </a:rPr>
-              <a:t>balance_τ  +  turn_τ</a:t>
-            </a:r>
-          </a:p>
-        </p:txBody>
-      </p:sp>
-      <p:sp>
-        <p:nvSpPr>
-          <p:cNvPr id="28" name="Down Arrow 27"/>
-          <p:cNvSpPr/>
-          <p:nvPr/>
-        </p:nvSpPr>
-        <p:spPr>
-          <a:xfrm>
-            <a:off x="9326880" y="4242816"/>
-            <a:ext cx="146304" cy="73152"/>
-          </a:xfrm>
-          <a:prstGeom prst="downArrow">
-            <a:avLst/>
-          </a:prstGeom>
-          <a:solidFill>
-            <a:srgbClr val="94A3B8"/>
-          </a:solidFill>
-          <a:ln>
-            <a:noFill/>
-          </a:ln>
-        </p:spPr>
-        <p:style>
-          <a:lnRef idx="1">
-            <a:schemeClr val="accent1"/>
-          </a:lnRef>
-          <a:fillRef idx="3">
-            <a:schemeClr val="accent1"/>
-          </a:fillRef>
-          <a:effectRef idx="2">
-            <a:schemeClr val="accent1"/>
-          </a:effectRef>
-          <a:fontRef idx="minor">
-            <a:schemeClr val="lt1"/>
-          </a:fontRef>
-        </p:style>
-        <p:txBody>
-          <a:bodyPr rtlCol="0" anchor="ctr"/>
-          <a:lstStyle/>
-          <a:p>
-            <a:pPr algn="ctr"/>
-          </a:p>
-        </p:txBody>
-      </p:sp>
-      <p:sp>
-        <p:nvSpPr>
-          <p:cNvPr id="29" name="Rounded Rectangle 28"/>
-          <p:cNvSpPr/>
-          <p:nvPr/>
-        </p:nvSpPr>
-        <p:spPr>
-          <a:xfrm>
-            <a:off x="7406640" y="4325112"/>
-            <a:ext cx="4206240" cy="566928"/>
-          </a:xfrm>
-          <a:prstGeom prst="roundRect">
-            <a:avLst>
-              <a:gd name="adj" fmla="val 8000"/>
-            </a:avLst>
-          </a:prstGeom>
-          <a:solidFill>
-            <a:srgbClr val="7F1D1D"/>
-          </a:solidFill>
-          <a:ln>
-            <a:noFill/>
-          </a:ln>
-        </p:spPr>
-        <p:style>
-          <a:lnRef idx="1">
-            <a:schemeClr val="accent1"/>
-          </a:lnRef>
-          <a:fillRef idx="3">
-            <a:schemeClr val="accent1"/>
-          </a:fillRef>
-          <a:effectRef idx="2">
-            <a:schemeClr val="accent1"/>
-          </a:effectRef>
-          <a:fontRef idx="minor">
-            <a:schemeClr val="lt1"/>
-          </a:fontRef>
-        </p:style>
-        <p:txBody>
-          <a:bodyPr rtlCol="0" anchor="ctr" wrap="square"/>
-          <a:lstStyle/>
-          <a:p>
-            <a:pPr algn="ctr">
-              <a:spcBef>
-                <a:spcPts val="100"/>
-              </a:spcBef>
-              <a:spcAft>
-                <a:spcPts val="100"/>
-              </a:spcAft>
-            </a:pPr>
-            <a:r>
-              <a:rPr sz="1200" b="1">
-                <a:solidFill>
-                  <a:srgbClr val="FFFFFF"/>
-                </a:solidFill>
-                <a:latin typeface="Microsoft YaHei"/>
-                <a:ea typeface="Microsoft YaHei"/>
-              </a:rPr>
-              <a:t>WheelMixer</a:t>
-            </a:r>
-          </a:p>
-          <a:p>
-            <a:pPr algn="ctr">
-              <a:spcBef>
-                <a:spcPts val="100"/>
-              </a:spcBef>
-              <a:spcAft>
-                <a:spcPts val="100"/>
-              </a:spcAft>
-            </a:pPr>
-            <a:r>
-              <a:rPr sz="1000" b="0">
-                <a:solidFill>
-                  <a:srgbClr val="E2E8F0"/>
-                </a:solidFill>
-                <a:latin typeface="Microsoft YaHei"/>
-                <a:ea typeface="Microsoft YaHei"/>
-              </a:rPr>
-              <a:t>L = bal − turn    R = bal + turn</a:t>
-            </a:r>
-          </a:p>
-        </p:txBody>
-      </p:sp>
-      <p:sp>
-        <p:nvSpPr>
-          <p:cNvPr id="30" name="Down Arrow 29"/>
-          <p:cNvSpPr/>
-          <p:nvPr/>
-        </p:nvSpPr>
-        <p:spPr>
-          <a:xfrm>
-            <a:off x="9326880" y="4901184"/>
-            <a:ext cx="146304" cy="73152"/>
-          </a:xfrm>
-          <a:prstGeom prst="downArrow">
-            <a:avLst/>
-          </a:prstGeom>
-          <a:solidFill>
-            <a:srgbClr val="94A3B8"/>
-          </a:solidFill>
-          <a:ln>
-            <a:noFill/>
-          </a:ln>
-        </p:spPr>
-        <p:style>
-          <a:lnRef idx="1">
-            <a:schemeClr val="accent1"/>
-          </a:lnRef>
-          <a:fillRef idx="3">
-            <a:schemeClr val="accent1"/>
-          </a:fillRef>
-          <a:effectRef idx="2">
-            <a:schemeClr val="accent1"/>
-          </a:effectRef>
-          <a:fontRef idx="minor">
-            <a:schemeClr val="lt1"/>
-          </a:fontRef>
-        </p:style>
-        <p:txBody>
-          <a:bodyPr rtlCol="0" anchor="ctr"/>
-          <a:lstStyle/>
-          <a:p>
-            <a:pPr algn="ctr"/>
-          </a:p>
-        </p:txBody>
-      </p:sp>
-      <p:sp>
-        <p:nvSpPr>
-          <p:cNvPr id="31" name="Rounded Rectangle 30"/>
-          <p:cNvSpPr/>
-          <p:nvPr/>
-        </p:nvSpPr>
-        <p:spPr>
-          <a:xfrm>
-            <a:off x="7406640" y="4983480"/>
-            <a:ext cx="4206240" cy="566928"/>
-          </a:xfrm>
-          <a:prstGeom prst="roundRect">
-            <a:avLst>
-              <a:gd name="adj" fmla="val 8000"/>
-            </a:avLst>
-          </a:prstGeom>
-          <a:solidFill>
-            <a:srgbClr val="334155"/>
-          </a:solidFill>
-          <a:ln>
-            <a:noFill/>
-          </a:ln>
-        </p:spPr>
-        <p:style>
-          <a:lnRef idx="1">
-            <a:schemeClr val="accent1"/>
-          </a:lnRef>
-          <a:fillRef idx="3">
-            <a:schemeClr val="accent1"/>
-          </a:fillRef>
-          <a:effectRef idx="2">
-            <a:schemeClr val="accent1"/>
-          </a:effectRef>
-          <a:fontRef idx="minor">
-            <a:schemeClr val="lt1"/>
-          </a:fontRef>
-        </p:style>
-        <p:txBody>
-          <a:bodyPr rtlCol="0" anchor="ctr" wrap="square"/>
-          <a:lstStyle/>
-          <a:p>
-            <a:pPr algn="ctr">
-              <a:spcBef>
-                <a:spcPts val="100"/>
-              </a:spcBef>
-              <a:spcAft>
-                <a:spcPts val="100"/>
-              </a:spcAft>
-            </a:pPr>
-            <a:r>
-              <a:rPr sz="1200" b="1">
-                <a:solidFill>
-                  <a:srgbClr val="FFFFFF"/>
-                </a:solidFill>
-                <a:latin typeface="Microsoft YaHei"/>
-                <a:ea typeface="Microsoft YaHei"/>
-              </a:rPr>
-              <a:t>SafetyLimiter → 左右轮力矩</a:t>
-            </a:r>
-          </a:p>
-        </p:txBody>
-      </p:sp>
-      <p:sp>
-        <p:nvSpPr>
-          <p:cNvPr id="32" name="Rounded Rectangle 31"/>
-          <p:cNvSpPr/>
-          <p:nvPr/>
-        </p:nvSpPr>
-        <p:spPr>
-          <a:xfrm>
-            <a:off x="365760" y="6263640"/>
-            <a:ext cx="11430000" cy="411480"/>
-          </a:xfrm>
-          <a:prstGeom prst="roundRect">
-            <a:avLst>
-              <a:gd name="adj" fmla="val 8000"/>
-            </a:avLst>
-          </a:prstGeom>
-          <a:solidFill>
-            <a:srgbClr val="EFF6FF"/>
-          </a:solidFill>
-          <a:ln w="15875">
-            <a:solidFill>
-              <a:srgbClr val="BFDBFE"/>
-            </a:solidFill>
-          </a:ln>
-        </p:spPr>
-        <p:style>
-          <a:lnRef idx="1">
-            <a:schemeClr val="accent1"/>
-          </a:lnRef>
-          <a:fillRef idx="3">
-            <a:schemeClr val="accent1"/>
-          </a:fillRef>
-          <a:effectRef idx="2">
-            <a:schemeClr val="accent1"/>
-          </a:effectRef>
-          <a:fontRef idx="minor">
-            <a:schemeClr val="lt1"/>
-          </a:fontRef>
-        </p:style>
-        <p:txBody>
-          <a:bodyPr rtlCol="0" anchor="ctr" wrap="square"/>
-          <a:lstStyle/>
-          <a:p>
-            <a:pPr algn="ctr">
-              <a:spcBef>
-                <a:spcPts val="100"/>
-              </a:spcBef>
-              <a:spcAft>
-                <a:spcPts val="100"/>
-              </a:spcAft>
-            </a:pPr>
-            <a:r>
-              <a:rPr sz="1200" b="0">
+            <a:r>
+              <a:rPr sz="1300" b="1">
                 <a:solidFill>
                   <a:srgbClr val="1E40AF"/>
                 </a:solidFill>
                 <a:latin typeface="Microsoft YaHei"/>
                 <a:ea typeface="Microsoft YaHei"/>
               </a:rPr>
-              <a:t>说明：本仓库已完成橙色「运动接口」与红色「平衡底层」；SLAM / Nav2 为上层扩展，通过 /cmd_vel 无缝对接。</a:t>
+              <a:t>use_sim_time
+= true</a:t>
+            </a:r>
+          </a:p>
+        </p:txBody>
+      </p:sp>
+      <p:sp>
+        <p:nvSpPr>
+          <p:cNvPr id="21" name="Rounded Rectangle 20"/>
+          <p:cNvSpPr/>
+          <p:nvPr/>
+        </p:nvSpPr>
+        <p:spPr>
+          <a:xfrm>
+            <a:off x="9692640" y="2971800"/>
+            <a:ext cx="1828800" cy="1005840"/>
+          </a:xfrm>
+          <a:prstGeom prst="roundRect">
+            <a:avLst>
+              <a:gd name="adj" fmla="val 12000"/>
+            </a:avLst>
+          </a:prstGeom>
+          <a:solidFill>
+            <a:srgbClr val="FFF7ED"/>
+          </a:solidFill>
+          <a:ln w="19050">
+            <a:solidFill>
+              <a:srgbClr val="FDBA74"/>
+            </a:solidFill>
+          </a:ln>
+        </p:spPr>
+        <p:style>
+          <a:lnRef idx="1">
+            <a:schemeClr val="accent1"/>
+          </a:lnRef>
+          <a:fillRef idx="3">
+            <a:schemeClr val="accent1"/>
+          </a:fillRef>
+          <a:effectRef idx="2">
+            <a:schemeClr val="accent1"/>
+          </a:effectRef>
+          <a:fontRef idx="minor">
+            <a:schemeClr val="lt1"/>
+          </a:fontRef>
+        </p:style>
+        <p:txBody>
+          <a:bodyPr rtlCol="0" anchor="ctr" wrap="square"/>
+          <a:lstStyle/>
+          <a:p>
+            <a:pPr algn="ctr"/>
+            <a:r>
+              <a:rPr sz="1300" b="1">
+                <a:solidFill>
+                  <a:srgbClr val="9A3412"/>
+                </a:solidFill>
+                <a:latin typeface="Microsoft YaHei"/>
+                <a:ea typeface="Microsoft YaHei"/>
+              </a:rPr>
+              <a:t>use_sim_time
+= false</a:t>
+            </a:r>
+          </a:p>
+        </p:txBody>
+      </p:sp>
+      <p:sp>
+        <p:nvSpPr>
+          <p:cNvPr id="22" name="TextBox 21"/>
+          <p:cNvSpPr txBox="1"/>
+          <p:nvPr/>
+        </p:nvSpPr>
+        <p:spPr>
+          <a:xfrm>
+            <a:off x="7589520" y="4114800"/>
+            <a:ext cx="1828800" cy="320040"/>
+          </a:xfrm>
+          <a:prstGeom prst="rect">
+            <a:avLst/>
+          </a:prstGeom>
+          <a:noFill/>
+        </p:spPr>
+        <p:txBody>
+          <a:bodyPr wrap="none">
+            <a:spAutoFit/>
+          </a:bodyPr>
+          <a:lstStyle/>
+          <a:p>
+            <a:pPr algn="ctr"/>
+            <a:r>
+              <a:rPr sz="1200" b="0">
+                <a:solidFill>
+                  <a:srgbClr val="64748B"/>
+                </a:solidFill>
+                <a:latin typeface="Microsoft YaHei"/>
+                <a:ea typeface="Microsoft YaHei"/>
+              </a:rPr>
+              <a:t>跟仿真钟</a:t>
+            </a:r>
+          </a:p>
+        </p:txBody>
+      </p:sp>
+      <p:sp>
+        <p:nvSpPr>
+          <p:cNvPr id="23" name="TextBox 22"/>
+          <p:cNvSpPr txBox="1"/>
+          <p:nvPr/>
+        </p:nvSpPr>
+        <p:spPr>
+          <a:xfrm>
+            <a:off x="9692640" y="4114800"/>
+            <a:ext cx="1828800" cy="320040"/>
+          </a:xfrm>
+          <a:prstGeom prst="rect">
+            <a:avLst/>
+          </a:prstGeom>
+          <a:noFill/>
+        </p:spPr>
+        <p:txBody>
+          <a:bodyPr wrap="none">
+            <a:spAutoFit/>
+          </a:bodyPr>
+          <a:lstStyle/>
+          <a:p>
+            <a:pPr algn="ctr"/>
+            <a:r>
+              <a:rPr sz="1200" b="0">
+                <a:solidFill>
+                  <a:srgbClr val="64748B"/>
+                </a:solidFill>
+                <a:latin typeface="Microsoft YaHei"/>
+                <a:ea typeface="Microsoft YaHei"/>
+              </a:rPr>
+              <a:t>跟墙钟</a:t>
+            </a:r>
+          </a:p>
+        </p:txBody>
+      </p:sp>
+      <p:sp>
+        <p:nvSpPr>
+          <p:cNvPr id="24" name="TextBox 23"/>
+          <p:cNvSpPr txBox="1"/>
+          <p:nvPr/>
+        </p:nvSpPr>
+        <p:spPr>
+          <a:xfrm>
+            <a:off x="7589520" y="4572000"/>
+            <a:ext cx="3931920" cy="640080"/>
+          </a:xfrm>
+          <a:prstGeom prst="rect">
+            <a:avLst/>
+          </a:prstGeom>
+          <a:noFill/>
+        </p:spPr>
+        <p:txBody>
+          <a:bodyPr wrap="none">
+            <a:spAutoFit/>
+          </a:bodyPr>
+          <a:lstStyle/>
+          <a:p>
+            <a:pPr algn="l"/>
+            <a:r>
+              <a:rPr sz="1200" b="0">
+                <a:solidFill>
+                  <a:srgbClr val="64748B"/>
+                </a:solidFill>
+                <a:latin typeface="Microsoft YaHei"/>
+                <a:ea typeface="Microsoft YaHei"/>
+              </a:rPr>
+              <a:t>/clock 过慢时，控制会跟着掉频；
+可提高 /clock 或改用墙钟。</a:t>
+            </a:r>
+          </a:p>
+        </p:txBody>
+      </p:sp>
+      <p:sp>
+        <p:nvSpPr>
+          <p:cNvPr id="25" name="Rectangle 24"/>
+          <p:cNvSpPr/>
+          <p:nvPr/>
+        </p:nvSpPr>
+        <p:spPr>
+          <a:xfrm>
+            <a:off x="457200" y="6126480"/>
+            <a:ext cx="11247120" cy="411480"/>
+          </a:xfrm>
+          <a:prstGeom prst="rect">
+            <a:avLst/>
+          </a:prstGeom>
+          <a:solidFill>
+            <a:srgbClr val="F1F5F9"/>
+          </a:solidFill>
+          <a:ln>
+            <a:noFill/>
+          </a:ln>
+        </p:spPr>
+        <p:style>
+          <a:lnRef idx="1">
+            <a:schemeClr val="accent1"/>
+          </a:lnRef>
+          <a:fillRef idx="3">
+            <a:schemeClr val="accent1"/>
+          </a:fillRef>
+          <a:effectRef idx="2">
+            <a:schemeClr val="accent1"/>
+          </a:effectRef>
+          <a:fontRef idx="minor">
+            <a:schemeClr val="lt1"/>
+          </a:fontRef>
+        </p:style>
+        <p:txBody>
+          <a:bodyPr rtlCol="0" anchor="ctr"/>
+          <a:lstStyle/>
+          <a:p>
+            <a:pPr algn="ctr"/>
+            <a:r>
+              <a:rPr sz="1300" b="0">
+                <a:solidFill>
+                  <a:srgbClr val="475569"/>
+                </a:solidFill>
+                <a:latin typeface="Microsoft YaHei"/>
+                <a:ea typeface="Microsoft YaHei"/>
+              </a:rPr>
+              <a:t>这一页只记框架：上层规划 → 标准接口 → 底层控制；时间源要和节点一致。</a:t>
             </a:r>
           </a:p>
         </p:txBody>

</xml_diff>

<commit_message>
Retitle framework PPT to differential-drive call chain
Use 二轮差速车 naming and emphasize familiarity with framework
invocation rather than ownership of changes.

Co-authored-by: zhangqiwen1112 <zhangqiwen1112@users.noreply.github.com>
</commit_message>
<xml_diff>
--- a/docs/framework_overview_one_page.pptx
+++ b/docs/framework_overview_one_page.pptx
@@ -3162,7 +3162,7 @@
                 <a:latin typeface="Microsoft YaHei"/>
                 <a:ea typeface="Microsoft YaHei"/>
               </a:rPr>
-              <a:t>熟悉的框架</a:t>
+              <a:t>二轮差速车 · 框架调用</a:t>
             </a:r>
           </a:p>
         </p:txBody>
@@ -3198,7 +3198,7 @@
                 <a:latin typeface="Microsoft YaHei"/>
                 <a:ea typeface="Microsoft YaHei"/>
               </a:rPr>
-              <a:t>主要收获：理清分层与接口；顺带踩过仿真时间同步</a:t>
+              <a:t>主要收获：熟悉这里各层怎么串起来调用</a:t>
             </a:r>
           </a:p>
         </p:txBody>
@@ -3449,7 +3449,7 @@
                 <a:latin typeface="Microsoft YaHei"/>
                 <a:ea typeface="Microsoft YaHei"/>
               </a:rPr>
-              <a:t>平衡 · 速度 · 偏航</a:t>
+              <a:t>底盘控制</a:t>
             </a:r>
           </a:p>
         </p:txBody>
@@ -3583,7 +3583,7 @@
                 <a:latin typeface="Microsoft YaHei"/>
                 <a:ea typeface="Microsoft YaHei"/>
               </a:rPr>
-              <a:t>← 接缝</a:t>
+              <a:t>← 调用接口</a:t>
             </a:r>
           </a:p>
         </p:txBody>
@@ -3596,15 +3596,15 @@
         </p:nvCxnSpPr>
         <p:spPr>
           <a:xfrm>
-            <a:off x="1508760.0" y="3246120"/>
-            <a:ext cx="0.0" cy="1664208"/>
+            <a:off x="1508760.0" y="1234440"/>
+            <a:ext cx="0.0" cy="3675888"/>
           </a:xfrm>
           <a:prstGeom prst="line">
             <a:avLst/>
           </a:prstGeom>
-          <a:ln w="31750">
+          <a:ln w="25400">
             <a:solidFill>
-              <a:srgbClr val="B91C1C"/>
+              <a:srgbClr val="64748B"/>
             </a:solidFill>
           </a:ln>
         </p:spPr>
@@ -3631,15 +3631,15 @@
         </p:nvCxnSpPr>
         <p:spPr>
           <a:xfrm>
-            <a:off x="1508760.0" y="3246120"/>
+            <a:off x="1508760.0" y="1234440"/>
             <a:ext cx="228600.0" cy="0"/>
           </a:xfrm>
           <a:prstGeom prst="line">
             <a:avLst/>
           </a:prstGeom>
-          <a:ln w="31750">
+          <a:ln w="25400">
             <a:solidFill>
-              <a:srgbClr val="B91C1C"/>
+              <a:srgbClr val="64748B"/>
             </a:solidFill>
           </a:ln>
         </p:spPr>
@@ -3672,9 +3672,9 @@
           <a:prstGeom prst="line">
             <a:avLst/>
           </a:prstGeom>
-          <a:ln w="31750">
+          <a:ln w="25400">
             <a:solidFill>
-              <a:srgbClr val="B91C1C"/>
+              <a:srgbClr val="64748B"/>
             </a:solidFill>
           </a:ln>
         </p:spPr>
@@ -3701,8 +3701,8 @@
         </p:nvSpPr>
         <p:spPr>
           <a:xfrm>
-            <a:off x="320040" y="3749040"/>
-            <a:ext cx="1280160" cy="457200"/>
+            <a:off x="228600" y="2743200"/>
+            <a:ext cx="1371600" cy="457200"/>
           </a:xfrm>
           <a:prstGeom prst="rect">
             <a:avLst/>
@@ -3717,14 +3717,14 @@
           <a:p>
             <a:pPr algn="ctr"/>
             <a:r>
-              <a:rPr sz="1300" b="1">
+              <a:rPr sz="1200" b="1">
                 <a:solidFill>
-                  <a:srgbClr val="B91C1C"/>
+                  <a:srgbClr val="475569"/>
                 </a:solidFill>
                 <a:latin typeface="Microsoft YaHei"/>
                 <a:ea typeface="Microsoft YaHei"/>
               </a:rPr>
-              <a:t>本仓库</a:t>
+              <a:t>熟悉调用链</a:t>
             </a:r>
           </a:p>
         </p:txBody>
@@ -4084,8 +4084,8 @@
                 <a:latin typeface="Microsoft YaHei"/>
                 <a:ea typeface="Microsoft YaHei"/>
               </a:rPr>
-              <a:t>/clock 过慢时，控制会跟着掉频；
-可提高 /clock 或改用墙钟。</a:t>
+              <a:t>调用时要选对时间源，
+否则节点频率对不上。</a:t>
             </a:r>
           </a:p>
         </p:txBody>
@@ -4138,7 +4138,7 @@
                 <a:latin typeface="Microsoft YaHei"/>
                 <a:ea typeface="Microsoft YaHei"/>
               </a:rPr>
-              <a:t>这一页只记框架：上层规划 → 标准接口 → 底层控制；时间源要和节点一致。</a:t>
+              <a:t>重点不是改了多少，而是搞清：谁调用谁、经哪条接口、时钟怎么对齐。</a:t>
             </a:r>
           </a:p>
         </p:txBody>

</xml_diff>

<commit_message>
Remove time sync section from framework PPT
Co-authored-by: zhangqiwen1112 <zhangqiwen1112@users.noreply.github.com>
</commit_message>
<xml_diff>
--- a/docs/framework_overview_one_page.pptx
+++ b/docs/framework_overview_one_page.pptx
@@ -3139,8 +3139,8 @@
         </p:nvSpPr>
         <p:spPr>
           <a:xfrm>
-            <a:off x="457200" y="256032"/>
-            <a:ext cx="10972800" cy="365760"/>
+            <a:off x="457200" y="320040"/>
+            <a:ext cx="10972800" cy="411480"/>
           </a:xfrm>
           <a:prstGeom prst="rect">
             <a:avLst/>
@@ -3155,7 +3155,7 @@
           <a:p>
             <a:pPr algn="l"/>
             <a:r>
-              <a:rPr sz="2800" b="1">
+              <a:rPr sz="3000" b="1">
                 <a:solidFill>
                   <a:srgbClr val="0F172A"/>
                 </a:solidFill>
@@ -3175,8 +3175,8 @@
         </p:nvSpPr>
         <p:spPr>
           <a:xfrm>
-            <a:off x="457200" y="640080"/>
-            <a:ext cx="10972800" cy="274320"/>
+            <a:off x="457200" y="777240"/>
+            <a:ext cx="10972800" cy="320040"/>
           </a:xfrm>
           <a:prstGeom prst="rect">
             <a:avLst/>
@@ -3191,7 +3191,7 @@
           <a:p>
             <a:pPr algn="l"/>
             <a:r>
-              <a:rPr sz="1400" b="0">
+              <a:rPr sz="1500" b="0">
                 <a:solidFill>
                   <a:srgbClr val="64748B"/>
                 </a:solidFill>
@@ -3211,8 +3211,8 @@
         </p:nvSpPr>
         <p:spPr>
           <a:xfrm>
-            <a:off x="1828800" y="1234440"/>
-            <a:ext cx="4023360" cy="658368"/>
+            <a:off x="3717950" y="1417320"/>
+            <a:ext cx="4754880" cy="777240"/>
           </a:xfrm>
           <a:prstGeom prst="roundRect">
             <a:avLst>
@@ -3246,7 +3246,7 @@
           <a:p>
             <a:pPr algn="ctr"/>
             <a:r>
-              <a:rPr sz="1800" b="1">
+              <a:rPr sz="2000" b="1">
                 <a:solidFill>
                   <a:srgbClr val="FFFFFF"/>
                 </a:solidFill>
@@ -3266,8 +3266,8 @@
         </p:nvSpPr>
         <p:spPr>
           <a:xfrm>
-            <a:off x="3739896" y="1938528"/>
-            <a:ext cx="201168" cy="237744"/>
+            <a:off x="5985662" y="2240280"/>
+            <a:ext cx="219456" cy="274320"/>
           </a:xfrm>
           <a:prstGeom prst="downArrow">
             <a:avLst/>
@@ -3309,8 +3309,8 @@
         </p:nvSpPr>
         <p:spPr>
           <a:xfrm>
-            <a:off x="1828800" y="2240280"/>
-            <a:ext cx="4023360" cy="658368"/>
+            <a:off x="3717950" y="2578608"/>
+            <a:ext cx="4754880" cy="777240"/>
           </a:xfrm>
           <a:prstGeom prst="roundRect">
             <a:avLst>
@@ -3344,7 +3344,7 @@
           <a:p>
             <a:pPr algn="ctr"/>
             <a:r>
-              <a:rPr sz="1800" b="1">
+              <a:rPr sz="2000" b="1">
                 <a:solidFill>
                   <a:srgbClr val="FFFFFF"/>
                 </a:solidFill>
@@ -3364,8 +3364,8 @@
         </p:nvSpPr>
         <p:spPr>
           <a:xfrm>
-            <a:off x="3739896" y="2944368"/>
-            <a:ext cx="201168" cy="237744"/>
+            <a:off x="5985662" y="3401568"/>
+            <a:ext cx="219456" cy="274320"/>
           </a:xfrm>
           <a:prstGeom prst="downArrow">
             <a:avLst/>
@@ -3407,8 +3407,8 @@
         </p:nvSpPr>
         <p:spPr>
           <a:xfrm>
-            <a:off x="1828800" y="3246120"/>
-            <a:ext cx="4023360" cy="658368"/>
+            <a:off x="3717950" y="3739896"/>
+            <a:ext cx="4754880" cy="777240"/>
           </a:xfrm>
           <a:prstGeom prst="roundRect">
             <a:avLst>
@@ -3442,7 +3442,7 @@
           <a:p>
             <a:pPr algn="ctr"/>
             <a:r>
-              <a:rPr sz="1800" b="1">
+              <a:rPr sz="2000" b="1">
                 <a:solidFill>
                   <a:srgbClr val="FFFFFF"/>
                 </a:solidFill>
@@ -3462,8 +3462,8 @@
         </p:nvSpPr>
         <p:spPr>
           <a:xfrm>
-            <a:off x="3739896" y="3950208"/>
-            <a:ext cx="201168" cy="237744"/>
+            <a:off x="5985662" y="4562856"/>
+            <a:ext cx="219456" cy="274320"/>
           </a:xfrm>
           <a:prstGeom prst="downArrow">
             <a:avLst/>
@@ -3505,8 +3505,8 @@
         </p:nvSpPr>
         <p:spPr>
           <a:xfrm>
-            <a:off x="1828800" y="4251960"/>
-            <a:ext cx="4023360" cy="658368"/>
+            <a:off x="3717950" y="4901184"/>
+            <a:ext cx="4754880" cy="777240"/>
           </a:xfrm>
           <a:prstGeom prst="roundRect">
             <a:avLst>
@@ -3540,7 +3540,7 @@
           <a:p>
             <a:pPr algn="ctr"/>
             <a:r>
-              <a:rPr sz="1800" b="1">
+              <a:rPr sz="2000" b="1">
                 <a:solidFill>
                   <a:srgbClr val="FFFFFF"/>
                 </a:solidFill>
@@ -3560,8 +3560,8 @@
         </p:nvSpPr>
         <p:spPr>
           <a:xfrm>
-            <a:off x="6035040" y="2423160"/>
-            <a:ext cx="1645920" cy="365760"/>
+            <a:off x="8701430" y="2807208"/>
+            <a:ext cx="2011680" cy="365760"/>
           </a:xfrm>
           <a:prstGeom prst="rect">
             <a:avLst/>
@@ -3576,7 +3576,7 @@
           <a:p>
             <a:pPr algn="l"/>
             <a:r>
-              <a:rPr sz="1300" b="1">
+              <a:rPr sz="1400" b="1">
                 <a:solidFill>
                   <a:srgbClr val="B45309"/>
                 </a:solidFill>
@@ -3596,13 +3596,13 @@
         </p:nvCxnSpPr>
         <p:spPr>
           <a:xfrm>
-            <a:off x="1508760.0" y="1234440"/>
-            <a:ext cx="0.0" cy="3675888"/>
+            <a:off x="3352190.0" y="1417320"/>
+            <a:ext cx="0.0" cy="4261104"/>
           </a:xfrm>
           <a:prstGeom prst="line">
             <a:avLst/>
           </a:prstGeom>
-          <a:ln w="25400">
+          <a:ln w="31750">
             <a:solidFill>
               <a:srgbClr val="64748B"/>
             </a:solidFill>
@@ -3631,13 +3631,13 @@
         </p:nvCxnSpPr>
         <p:spPr>
           <a:xfrm>
-            <a:off x="1508760.0" y="1234440"/>
-            <a:ext cx="228600.0" cy="0"/>
+            <a:off x="3352190.0" y="1417320"/>
+            <a:ext cx="256032.0" cy="0"/>
           </a:xfrm>
           <a:prstGeom prst="line">
             <a:avLst/>
           </a:prstGeom>
-          <a:ln w="25400">
+          <a:ln w="31750">
             <a:solidFill>
               <a:srgbClr val="64748B"/>
             </a:solidFill>
@@ -3666,13 +3666,13 @@
         </p:nvCxnSpPr>
         <p:spPr>
           <a:xfrm>
-            <a:off x="1508760.0" y="4910328"/>
-            <a:ext cx="228600.0" cy="0"/>
+            <a:off x="3352190.0" y="5678424"/>
+            <a:ext cx="256032.0" cy="0"/>
           </a:xfrm>
           <a:prstGeom prst="line">
             <a:avLst/>
           </a:prstGeom>
-          <a:ln w="25400">
+          <a:ln w="31750">
             <a:solidFill>
               <a:srgbClr val="64748B"/>
             </a:solidFill>
@@ -3701,8 +3701,8 @@
         </p:nvSpPr>
         <p:spPr>
           <a:xfrm>
-            <a:off x="228600" y="2743200"/>
-            <a:ext cx="1371600" cy="457200"/>
+            <a:off x="502920" y="3410712"/>
+            <a:ext cx="1645920" cy="365760"/>
           </a:xfrm>
           <a:prstGeom prst="rect">
             <a:avLst/>
@@ -3717,7 +3717,7 @@
           <a:p>
             <a:pPr algn="ctr"/>
             <a:r>
-              <a:rPr sz="1200" b="1">
+              <a:rPr sz="1300" b="1">
                 <a:solidFill>
                   <a:srgbClr val="475569"/>
                 </a:solidFill>
@@ -3731,375 +3731,14 @@
       </p:sp>
       <p:sp>
         <p:nvSpPr>
-          <p:cNvPr id="17" name="TextBox 16"/>
-          <p:cNvSpPr txBox="1"/>
+          <p:cNvPr id="17" name="Rectangle 16"/>
+          <p:cNvSpPr/>
           <p:nvPr/>
         </p:nvSpPr>
         <p:spPr>
           <a:xfrm>
-            <a:off x="7589520" y="1234440"/>
-            <a:ext cx="4114800" cy="320040"/>
-          </a:xfrm>
-          <a:prstGeom prst="rect">
-            <a:avLst/>
-          </a:prstGeom>
-          <a:noFill/>
-        </p:spPr>
-        <p:txBody>
-          <a:bodyPr wrap="none">
-            <a:spAutoFit/>
-          </a:bodyPr>
-          <a:lstStyle/>
-          <a:p>
-            <a:pPr algn="l"/>
-            <a:r>
-              <a:rPr sz="1600" b="1">
-                <a:solidFill>
-                  <a:srgbClr val="0F172A"/>
-                </a:solidFill>
-                <a:latin typeface="Microsoft YaHei"/>
-                <a:ea typeface="Microsoft YaHei"/>
-              </a:rPr>
-              <a:t>时间同步</a:t>
-            </a:r>
-          </a:p>
-        </p:txBody>
-      </p:sp>
-      <p:sp>
-        <p:nvSpPr>
-          <p:cNvPr id="18" name="Rounded Rectangle 17"/>
-          <p:cNvSpPr/>
-          <p:nvPr/>
-        </p:nvSpPr>
-        <p:spPr>
-          <a:xfrm>
-            <a:off x="7589520" y="1737360"/>
-            <a:ext cx="3931920" cy="777240"/>
-          </a:xfrm>
-          <a:prstGeom prst="roundRect">
-            <a:avLst>
-              <a:gd name="adj" fmla="val 12000"/>
-            </a:avLst>
-          </a:prstGeom>
-          <a:solidFill>
-            <a:srgbClr val="FFFFFF"/>
-          </a:solidFill>
-          <a:ln w="19050">
-            <a:solidFill>
-              <a:srgbClr val="BFDBFE"/>
-            </a:solidFill>
-          </a:ln>
-        </p:spPr>
-        <p:style>
-          <a:lnRef idx="1">
-            <a:schemeClr val="accent1"/>
-          </a:lnRef>
-          <a:fillRef idx="3">
-            <a:schemeClr val="accent1"/>
-          </a:fillRef>
-          <a:effectRef idx="2">
-            <a:schemeClr val="accent1"/>
-          </a:effectRef>
-          <a:fontRef idx="minor">
-            <a:schemeClr val="lt1"/>
-          </a:fontRef>
-        </p:style>
-        <p:txBody>
-          <a:bodyPr rtlCol="0" anchor="ctr" wrap="square"/>
-          <a:lstStyle/>
-          <a:p>
-            <a:pPr algn="ctr"/>
-            <a:r>
-              <a:rPr sz="1600" b="1">
-                <a:solidFill>
-                  <a:srgbClr val="1E40AF"/>
-                </a:solidFill>
-                <a:latin typeface="Microsoft YaHei"/>
-                <a:ea typeface="Microsoft YaHei"/>
-              </a:rPr>
-              <a:t>Gazebo  /clock</a:t>
-            </a:r>
-          </a:p>
-        </p:txBody>
-      </p:sp>
-      <p:sp>
-        <p:nvSpPr>
-          <p:cNvPr id="19" name="Down Arrow 18"/>
-          <p:cNvSpPr/>
-          <p:nvPr/>
-        </p:nvSpPr>
-        <p:spPr>
-          <a:xfrm>
-            <a:off x="9454896" y="2606040"/>
-            <a:ext cx="201168" cy="256032"/>
-          </a:xfrm>
-          <a:prstGeom prst="downArrow">
-            <a:avLst/>
-          </a:prstGeom>
-          <a:solidFill>
-            <a:srgbClr val="94A3B8"/>
-          </a:solidFill>
-          <a:ln>
-            <a:noFill/>
-          </a:ln>
-        </p:spPr>
-        <p:style>
-          <a:lnRef idx="1">
-            <a:schemeClr val="accent1"/>
-          </a:lnRef>
-          <a:fillRef idx="3">
-            <a:schemeClr val="accent1"/>
-          </a:fillRef>
-          <a:effectRef idx="2">
-            <a:schemeClr val="accent1"/>
-          </a:effectRef>
-          <a:fontRef idx="minor">
-            <a:schemeClr val="lt1"/>
-          </a:fontRef>
-        </p:style>
-        <p:txBody>
-          <a:bodyPr rtlCol="0" anchor="ctr"/>
-          <a:lstStyle/>
-          <a:p>
-            <a:pPr algn="ctr"/>
-          </a:p>
-        </p:txBody>
-      </p:sp>
-      <p:sp>
-        <p:nvSpPr>
-          <p:cNvPr id="20" name="Rounded Rectangle 19"/>
-          <p:cNvSpPr/>
-          <p:nvPr/>
-        </p:nvSpPr>
-        <p:spPr>
-          <a:xfrm>
-            <a:off x="7589520" y="2971800"/>
-            <a:ext cx="1828800" cy="1005840"/>
-          </a:xfrm>
-          <a:prstGeom prst="roundRect">
-            <a:avLst>
-              <a:gd name="adj" fmla="val 12000"/>
-            </a:avLst>
-          </a:prstGeom>
-          <a:solidFill>
-            <a:srgbClr val="EFF6FF"/>
-          </a:solidFill>
-          <a:ln w="19050">
-            <a:solidFill>
-              <a:srgbClr val="93C5FD"/>
-            </a:solidFill>
-          </a:ln>
-        </p:spPr>
-        <p:style>
-          <a:lnRef idx="1">
-            <a:schemeClr val="accent1"/>
-          </a:lnRef>
-          <a:fillRef idx="3">
-            <a:schemeClr val="accent1"/>
-          </a:fillRef>
-          <a:effectRef idx="2">
-            <a:schemeClr val="accent1"/>
-          </a:effectRef>
-          <a:fontRef idx="minor">
-            <a:schemeClr val="lt1"/>
-          </a:fontRef>
-        </p:style>
-        <p:txBody>
-          <a:bodyPr rtlCol="0" anchor="ctr" wrap="square"/>
-          <a:lstStyle/>
-          <a:p>
-            <a:pPr algn="ctr"/>
-            <a:r>
-              <a:rPr sz="1300" b="1">
-                <a:solidFill>
-                  <a:srgbClr val="1E40AF"/>
-                </a:solidFill>
-                <a:latin typeface="Microsoft YaHei"/>
-                <a:ea typeface="Microsoft YaHei"/>
-              </a:rPr>
-              <a:t>use_sim_time
-= true</a:t>
-            </a:r>
-          </a:p>
-        </p:txBody>
-      </p:sp>
-      <p:sp>
-        <p:nvSpPr>
-          <p:cNvPr id="21" name="Rounded Rectangle 20"/>
-          <p:cNvSpPr/>
-          <p:nvPr/>
-        </p:nvSpPr>
-        <p:spPr>
-          <a:xfrm>
-            <a:off x="9692640" y="2971800"/>
-            <a:ext cx="1828800" cy="1005840"/>
-          </a:xfrm>
-          <a:prstGeom prst="roundRect">
-            <a:avLst>
-              <a:gd name="adj" fmla="val 12000"/>
-            </a:avLst>
-          </a:prstGeom>
-          <a:solidFill>
-            <a:srgbClr val="FFF7ED"/>
-          </a:solidFill>
-          <a:ln w="19050">
-            <a:solidFill>
-              <a:srgbClr val="FDBA74"/>
-            </a:solidFill>
-          </a:ln>
-        </p:spPr>
-        <p:style>
-          <a:lnRef idx="1">
-            <a:schemeClr val="accent1"/>
-          </a:lnRef>
-          <a:fillRef idx="3">
-            <a:schemeClr val="accent1"/>
-          </a:fillRef>
-          <a:effectRef idx="2">
-            <a:schemeClr val="accent1"/>
-          </a:effectRef>
-          <a:fontRef idx="minor">
-            <a:schemeClr val="lt1"/>
-          </a:fontRef>
-        </p:style>
-        <p:txBody>
-          <a:bodyPr rtlCol="0" anchor="ctr" wrap="square"/>
-          <a:lstStyle/>
-          <a:p>
-            <a:pPr algn="ctr"/>
-            <a:r>
-              <a:rPr sz="1300" b="1">
-                <a:solidFill>
-                  <a:srgbClr val="9A3412"/>
-                </a:solidFill>
-                <a:latin typeface="Microsoft YaHei"/>
-                <a:ea typeface="Microsoft YaHei"/>
-              </a:rPr>
-              <a:t>use_sim_time
-= false</a:t>
-            </a:r>
-          </a:p>
-        </p:txBody>
-      </p:sp>
-      <p:sp>
-        <p:nvSpPr>
-          <p:cNvPr id="22" name="TextBox 21"/>
-          <p:cNvSpPr txBox="1"/>
-          <p:nvPr/>
-        </p:nvSpPr>
-        <p:spPr>
-          <a:xfrm>
-            <a:off x="7589520" y="4114800"/>
-            <a:ext cx="1828800" cy="320040"/>
-          </a:xfrm>
-          <a:prstGeom prst="rect">
-            <a:avLst/>
-          </a:prstGeom>
-          <a:noFill/>
-        </p:spPr>
-        <p:txBody>
-          <a:bodyPr wrap="none">
-            <a:spAutoFit/>
-          </a:bodyPr>
-          <a:lstStyle/>
-          <a:p>
-            <a:pPr algn="ctr"/>
-            <a:r>
-              <a:rPr sz="1200" b="0">
-                <a:solidFill>
-                  <a:srgbClr val="64748B"/>
-                </a:solidFill>
-                <a:latin typeface="Microsoft YaHei"/>
-                <a:ea typeface="Microsoft YaHei"/>
-              </a:rPr>
-              <a:t>跟仿真钟</a:t>
-            </a:r>
-          </a:p>
-        </p:txBody>
-      </p:sp>
-      <p:sp>
-        <p:nvSpPr>
-          <p:cNvPr id="23" name="TextBox 22"/>
-          <p:cNvSpPr txBox="1"/>
-          <p:nvPr/>
-        </p:nvSpPr>
-        <p:spPr>
-          <a:xfrm>
-            <a:off x="9692640" y="4114800"/>
-            <a:ext cx="1828800" cy="320040"/>
-          </a:xfrm>
-          <a:prstGeom prst="rect">
-            <a:avLst/>
-          </a:prstGeom>
-          <a:noFill/>
-        </p:spPr>
-        <p:txBody>
-          <a:bodyPr wrap="none">
-            <a:spAutoFit/>
-          </a:bodyPr>
-          <a:lstStyle/>
-          <a:p>
-            <a:pPr algn="ctr"/>
-            <a:r>
-              <a:rPr sz="1200" b="0">
-                <a:solidFill>
-                  <a:srgbClr val="64748B"/>
-                </a:solidFill>
-                <a:latin typeface="Microsoft YaHei"/>
-                <a:ea typeface="Microsoft YaHei"/>
-              </a:rPr>
-              <a:t>跟墙钟</a:t>
-            </a:r>
-          </a:p>
-        </p:txBody>
-      </p:sp>
-      <p:sp>
-        <p:nvSpPr>
-          <p:cNvPr id="24" name="TextBox 23"/>
-          <p:cNvSpPr txBox="1"/>
-          <p:nvPr/>
-        </p:nvSpPr>
-        <p:spPr>
-          <a:xfrm>
-            <a:off x="7589520" y="4572000"/>
-            <a:ext cx="3931920" cy="640080"/>
-          </a:xfrm>
-          <a:prstGeom prst="rect">
-            <a:avLst/>
-          </a:prstGeom>
-          <a:noFill/>
-        </p:spPr>
-        <p:txBody>
-          <a:bodyPr wrap="none">
-            <a:spAutoFit/>
-          </a:bodyPr>
-          <a:lstStyle/>
-          <a:p>
-            <a:pPr algn="l"/>
-            <a:r>
-              <a:rPr sz="1200" b="0">
-                <a:solidFill>
-                  <a:srgbClr val="64748B"/>
-                </a:solidFill>
-                <a:latin typeface="Microsoft YaHei"/>
-                <a:ea typeface="Microsoft YaHei"/>
-              </a:rPr>
-              <a:t>调用时要选对时间源，
-否则节点频率对不上。</a:t>
-            </a:r>
-          </a:p>
-        </p:txBody>
-      </p:sp>
-      <p:sp>
-        <p:nvSpPr>
-          <p:cNvPr id="25" name="Rectangle 24"/>
-          <p:cNvSpPr/>
-          <p:nvPr/>
-        </p:nvSpPr>
-        <p:spPr>
-          <a:xfrm>
-            <a:off x="457200" y="6126480"/>
-            <a:ext cx="11247120" cy="411480"/>
+            <a:off x="457200" y="6263640"/>
+            <a:ext cx="11247120" cy="365760"/>
           </a:xfrm>
           <a:prstGeom prst="rect">
             <a:avLst/>
@@ -4138,7 +3777,7 @@
                 <a:latin typeface="Microsoft YaHei"/>
                 <a:ea typeface="Microsoft YaHei"/>
               </a:rPr>
-              <a:t>重点不是改了多少，而是搞清：谁调用谁、经哪条接口、时钟怎么对齐。</a:t>
+              <a:t>搞清：谁调用谁、经哪条接口。</a:t>
             </a:r>
           </a:p>
         </p:txBody>

</xml_diff>

<commit_message>
Remove footer caption from framework PPT
Co-authored-by: zhangqiwen1112 <zhangqiwen1112@users.noreply.github.com>
</commit_message>
<xml_diff>
--- a/docs/framework_overview_one_page.pptx
+++ b/docs/framework_overview_one_page.pptx
@@ -3211,8 +3211,8 @@
         </p:nvSpPr>
         <p:spPr>
           <a:xfrm>
-            <a:off x="3717950" y="1417320"/>
-            <a:ext cx="4754880" cy="777240"/>
+            <a:off x="3717950" y="1554480"/>
+            <a:ext cx="4754880" cy="822960"/>
           </a:xfrm>
           <a:prstGeom prst="roundRect">
             <a:avLst>
@@ -3266,8 +3266,8 @@
         </p:nvSpPr>
         <p:spPr>
           <a:xfrm>
-            <a:off x="5985662" y="2240280"/>
-            <a:ext cx="219456" cy="274320"/>
+            <a:off x="5985662" y="2432304"/>
+            <a:ext cx="219456" cy="292608"/>
           </a:xfrm>
           <a:prstGeom prst="downArrow">
             <a:avLst/>
@@ -3309,8 +3309,8 @@
         </p:nvSpPr>
         <p:spPr>
           <a:xfrm>
-            <a:off x="3717950" y="2578608"/>
-            <a:ext cx="4754880" cy="777240"/>
+            <a:off x="3717950" y="2788920"/>
+            <a:ext cx="4754880" cy="822960"/>
           </a:xfrm>
           <a:prstGeom prst="roundRect">
             <a:avLst>
@@ -3364,8 +3364,8 @@
         </p:nvSpPr>
         <p:spPr>
           <a:xfrm>
-            <a:off x="5985662" y="3401568"/>
-            <a:ext cx="219456" cy="274320"/>
+            <a:off x="5985662" y="3666744"/>
+            <a:ext cx="219456" cy="292608"/>
           </a:xfrm>
           <a:prstGeom prst="downArrow">
             <a:avLst/>
@@ -3407,8 +3407,8 @@
         </p:nvSpPr>
         <p:spPr>
           <a:xfrm>
-            <a:off x="3717950" y="3739896"/>
-            <a:ext cx="4754880" cy="777240"/>
+            <a:off x="3717950" y="4023360"/>
+            <a:ext cx="4754880" cy="822960"/>
           </a:xfrm>
           <a:prstGeom prst="roundRect">
             <a:avLst>
@@ -3462,8 +3462,8 @@
         </p:nvSpPr>
         <p:spPr>
           <a:xfrm>
-            <a:off x="5985662" y="4562856"/>
-            <a:ext cx="219456" cy="274320"/>
+            <a:off x="5985662" y="4901184"/>
+            <a:ext cx="219456" cy="292608"/>
           </a:xfrm>
           <a:prstGeom prst="downArrow">
             <a:avLst/>
@@ -3505,8 +3505,8 @@
         </p:nvSpPr>
         <p:spPr>
           <a:xfrm>
-            <a:off x="3717950" y="4901184"/>
-            <a:ext cx="4754880" cy="777240"/>
+            <a:off x="3717950" y="5257800"/>
+            <a:ext cx="4754880" cy="822960"/>
           </a:xfrm>
           <a:prstGeom prst="roundRect">
             <a:avLst>
@@ -3560,7 +3560,7 @@
         </p:nvSpPr>
         <p:spPr>
           <a:xfrm>
-            <a:off x="8701430" y="2807208"/>
+            <a:off x="8701430" y="3044952"/>
             <a:ext cx="2011680" cy="365760"/>
           </a:xfrm>
           <a:prstGeom prst="rect">
@@ -3596,8 +3596,8 @@
         </p:nvCxnSpPr>
         <p:spPr>
           <a:xfrm>
-            <a:off x="3352190.0" y="1417320"/>
-            <a:ext cx="0.0" cy="4261104"/>
+            <a:off x="3352190.0" y="1554480"/>
+            <a:ext cx="0.0" cy="4526280"/>
           </a:xfrm>
           <a:prstGeom prst="line">
             <a:avLst/>
@@ -3631,7 +3631,7 @@
         </p:nvCxnSpPr>
         <p:spPr>
           <a:xfrm>
-            <a:off x="3352190.0" y="1417320"/>
+            <a:off x="3352190.0" y="1554480"/>
             <a:ext cx="256032.0" cy="0"/>
           </a:xfrm>
           <a:prstGeom prst="line">
@@ -3666,7 +3666,7 @@
         </p:nvCxnSpPr>
         <p:spPr>
           <a:xfrm>
-            <a:off x="3352190.0" y="5678424"/>
+            <a:off x="3352190.0" y="6080760"/>
             <a:ext cx="256032.0" cy="0"/>
           </a:xfrm>
           <a:prstGeom prst="line">
@@ -3701,7 +3701,7 @@
         </p:nvSpPr>
         <p:spPr>
           <a:xfrm>
-            <a:off x="502920" y="3410712"/>
+            <a:off x="502920" y="3680460"/>
             <a:ext cx="1645920" cy="365760"/>
           </a:xfrm>
           <a:prstGeom prst="rect">
@@ -3725,59 +3725,6 @@
                 <a:ea typeface="Microsoft YaHei"/>
               </a:rPr>
               <a:t>熟悉调用链</a:t>
-            </a:r>
-          </a:p>
-        </p:txBody>
-      </p:sp>
-      <p:sp>
-        <p:nvSpPr>
-          <p:cNvPr id="17" name="Rectangle 16"/>
-          <p:cNvSpPr/>
-          <p:nvPr/>
-        </p:nvSpPr>
-        <p:spPr>
-          <a:xfrm>
-            <a:off x="457200" y="6263640"/>
-            <a:ext cx="11247120" cy="365760"/>
-          </a:xfrm>
-          <a:prstGeom prst="rect">
-            <a:avLst/>
-          </a:prstGeom>
-          <a:solidFill>
-            <a:srgbClr val="F1F5F9"/>
-          </a:solidFill>
-          <a:ln>
-            <a:noFill/>
-          </a:ln>
-        </p:spPr>
-        <p:style>
-          <a:lnRef idx="1">
-            <a:schemeClr val="accent1"/>
-          </a:lnRef>
-          <a:fillRef idx="3">
-            <a:schemeClr val="accent1"/>
-          </a:fillRef>
-          <a:effectRef idx="2">
-            <a:schemeClr val="accent1"/>
-          </a:effectRef>
-          <a:fontRef idx="minor">
-            <a:schemeClr val="lt1"/>
-          </a:fontRef>
-        </p:style>
-        <p:txBody>
-          <a:bodyPr rtlCol="0" anchor="ctr"/>
-          <a:lstStyle/>
-          <a:p>
-            <a:pPr algn="ctr"/>
-            <a:r>
-              <a:rPr sz="1300" b="0">
-                <a:solidFill>
-                  <a:srgbClr val="475569"/>
-                </a:solidFill>
-                <a:latin typeface="Microsoft YaHei"/>
-                <a:ea typeface="Microsoft YaHei"/>
-              </a:rPr>
-              <a:t>搞清：谁调用谁、经哪条接口。</a:t>
             </a:r>
           </a:p>
         </p:txBody>

</xml_diff>